<commit_message>
Territory presentations: visible ask, bold answer areas, discussion lines
Each slide states the ask in plain words. Answer cells and boxes are
empty and formatted so typed text is bold and dark. Wins get more room
than the loss. A for-the-room line on the discussion slides.

Co-Authored-By: Claude Fable 5.1 <noreply@anthropic.com>
Claude-Session: https://claude.ai/code/session_01NccKroytcPyz54UophNQtq
</commit_message>
<xml_diff>
--- a/decks/territory-review/National Account Presentation - Mac.pptx
+++ b/decks/territory-review/National Account Presentation - Mac.pptx
@@ -507,7 +507,7 @@
           <a:lstStyle/>
           <a:p>
             <a:r>
-              <a:t>Ten minutes. Six slides. Real accounts and job names. No new data pulls. Pricing gets its own block on Day 2, leave it out of this one.</a:t>
+              <a:t>Ten minutes. Six slides. Real names, real jobs. No new data pulls. Pricing gets its own block on Day 2, leave it out of this one.</a:t>
             </a:r>
           </a:p>
         </p:txBody>
@@ -577,7 +577,7 @@
           <a:lstStyle/>
           <a:p>
             <a:r>
-              <a:t>Slide 1. Pre-filled. Add two sentences on what the numbers don't show.</a:t>
+              <a:t>Slide 1. Pre-filled by Nate. Add two sentences on what the numbers don't show. Two minutes, then move on.</a:t>
             </a:r>
           </a:p>
         </p:txBody>
@@ -857,7 +857,7 @@
           <a:lstStyle/>
           <a:p>
             <a:r>
-              <a:t>Slide 5. Three wins, one loss. For each win: the job, the competitor, and what won it. For the loss: what decided it, and what we could have done differently. Real jobs, real names. If the loss came down to the number, say what else was true.</a:t>
+              <a:t>Slide 5. Three wins, one loss. Real jobs, real names. Spend most of the time on the wins: what won it and whether the rest of the team can do the same thing. On the loss, what decided it and what we could have done differently. If it came down to the number, say what else was true.</a:t>
             </a:r>
           </a:p>
         </p:txBody>
@@ -9680,35 +9680,14 @@
           <a:lstStyle/>
           <a:p>
             <a:r>
-              <a:t>[One line on what the numbers say.]</a:t>
-            </a:r>
-          </a:p>
-        </p:txBody>
-      </p:sp>
-      <p:sp>
-        <p:nvSpPr>
-          <p:cNvPr id="6" name="Text Placeholder 5"/>
-          <p:cNvSpPr>
-            <a:spLocks noGrp="1"/>
-          </p:cNvSpPr>
-          <p:nvPr>
-            <p:ph type="body" idx="104"/>
-          </p:nvPr>
-        </p:nvSpPr>
-        <p:spPr/>
-        <p:txBody>
-          <a:bodyPr/>
-          <a:lstStyle/>
-          <a:p>
-            <a:r>
-              <a:t>Source: [system], pulled [date]. Quotes are a count. Pre-filled by Nate.</a:t>
-            </a:r>
-          </a:p>
-        </p:txBody>
-      </p:sp>
-      <p:sp>
-        <p:nvSpPr>
-          <p:cNvPr id="7" name="TextBox 6"/>
+              <a:t>Numbers are pre-filled. Add two sentences on what they don't show.</a:t>
+            </a:r>
+          </a:p>
+        </p:txBody>
+      </p:sp>
+      <p:sp>
+        <p:nvSpPr>
+          <p:cNvPr id="5" name="TextBox 4"/>
           <p:cNvSpPr txBox="1"/>
           <p:nvPr/>
         </p:nvSpPr>
@@ -9723,26 +9702,27 @@
           <a:noFill/>
         </p:spPr>
         <p:txBody>
-          <a:bodyPr wrap="square" anchor="t" lIns="0" rIns="0" tIns="0" bIns="0">
+          <a:bodyPr wrap="square" lIns="0" rIns="0" tIns="0" bIns="0">
             <a:noAutofit/>
           </a:bodyPr>
           <a:lstStyle/>
           <a:p>
-            <a:r>
-              <a:rPr sz="1100" b="1">
+            <a:pPr algn="l"/>
+            <a:r>
+              <a:rPr sz="1100" b="1" i="0">
                 <a:solidFill>
                   <a:srgbClr val="3C7D4D"/>
                 </a:solidFill>
                 <a:latin typeface="Arial"/>
               </a:rPr>
-              <a:t>BOOKINGS AND QUOTES BY QUARTER  ·  PRE-FILLED</a:t>
+              <a:t>BOOKINGS AND QUOTES BY QUARTER</a:t>
             </a:r>
           </a:p>
         </p:txBody>
       </p:sp>
       <p:graphicFrame>
         <p:nvGraphicFramePr>
-          <p:cNvPr id="8" name="Table 7"/>
+          <p:cNvPr id="6" name="Table 5"/>
           <p:cNvGraphicFramePr>
             <a:graphicFrameLocks noGrp="1"/>
           </p:cNvGraphicFramePr>
@@ -9750,7 +9730,7 @@
         </p:nvGraphicFramePr>
         <p:xfrm>
           <a:off x="731520" y="2377440"/>
-          <a:ext cx="5120640" cy="1600200"/>
+          <a:ext cx="5120640" cy="1664208"/>
         </p:xfrm>
         <a:graphic>
           <a:graphicData uri="http://schemas.openxmlformats.org/drawingml/2006/table">
@@ -9762,7 +9742,7 @@
                 <a:gridCol w="1280160"/>
                 <a:gridCol w="1280160"/>
               </a:tblGrid>
-              <a:tr h="274320">
+              <a:tr h="292608">
                 <a:tc>
                   <a:txBody>
                     <a:bodyPr/>
@@ -9948,7 +9928,7 @@
                   </a:tcPr>
                 </a:tc>
               </a:tr>
-              <a:tr h="265176">
+              <a:tr h="274320">
                 <a:tc>
                   <a:txBody>
                     <a:bodyPr/>
@@ -9957,7 +9937,7 @@
                       <a:r>
                         <a:rPr sz="1000" b="1">
                           <a:solidFill>
-                            <a:srgbClr val="15181A"/>
+                            <a:srgbClr val="5B6670"/>
                           </a:solidFill>
                           <a:latin typeface="Arial"/>
                         </a:rPr>
@@ -9965,9 +9945,9 @@
                       </a:r>
                     </a:p>
                   </a:txBody>
-                  <a:tcPr marL="73152" marR="73152" marT="27432" marB="27432" anchor="t">
+                  <a:tcPr marL="73152" marR="73152" marT="36576" marB="36576" anchor="t">
                     <a:solidFill>
-                      <a:srgbClr val="FFFFFF"/>
+                      <a:srgbClr val="F2F5F2"/>
                     </a:solidFill>
                     <a:lnL w="6350" cap="flat" cmpd="sng" algn="ctr">
                       <a:solidFill>
@@ -10000,18 +9980,15 @@
                     <a:bodyPr/>
                     <a:lstStyle/>
                     <a:p>
-                      <a:r>
-                        <a:rPr sz="1000" b="0">
-                          <a:solidFill>
-                            <a:srgbClr val="5B6670"/>
-                          </a:solidFill>
-                          <a:latin typeface="Arial"/>
-                        </a:rPr>
-                        <a:t/>
-                      </a:r>
+                      <a:endParaRPr lang="en-US" sz="1200" b="1">
+                        <a:solidFill>
+                          <a:srgbClr val="15181A"/>
+                        </a:solidFill>
+                        <a:latin typeface="Arial"/>
+                      </a:endParaRPr>
                     </a:p>
                   </a:txBody>
-                  <a:tcPr marL="73152" marR="73152" marT="27432" marB="27432" anchor="t">
+                  <a:tcPr marL="73152" marR="73152" marT="36576" marB="36576" anchor="t">
                     <a:solidFill>
                       <a:srgbClr val="FFFFFF"/>
                     </a:solidFill>
@@ -10046,18 +10023,15 @@
                     <a:bodyPr/>
                     <a:lstStyle/>
                     <a:p>
-                      <a:r>
-                        <a:rPr sz="1000" b="0">
-                          <a:solidFill>
-                            <a:srgbClr val="5B6670"/>
-                          </a:solidFill>
-                          <a:latin typeface="Arial"/>
-                        </a:rPr>
-                        <a:t/>
-                      </a:r>
+                      <a:endParaRPr lang="en-US" sz="1200" b="1">
+                        <a:solidFill>
+                          <a:srgbClr val="15181A"/>
+                        </a:solidFill>
+                        <a:latin typeface="Arial"/>
+                      </a:endParaRPr>
                     </a:p>
                   </a:txBody>
-                  <a:tcPr marL="73152" marR="73152" marT="27432" marB="27432" anchor="t">
+                  <a:tcPr marL="73152" marR="73152" marT="36576" marB="36576" anchor="t">
                     <a:solidFill>
                       <a:srgbClr val="FFFFFF"/>
                     </a:solidFill>
@@ -10092,18 +10066,15 @@
                     <a:bodyPr/>
                     <a:lstStyle/>
                     <a:p>
-                      <a:r>
-                        <a:rPr sz="1000" b="0">
-                          <a:solidFill>
-                            <a:srgbClr val="5B6670"/>
-                          </a:solidFill>
-                          <a:latin typeface="Arial"/>
-                        </a:rPr>
-                        <a:t/>
-                      </a:r>
+                      <a:endParaRPr lang="en-US" sz="1200" b="1">
+                        <a:solidFill>
+                          <a:srgbClr val="15181A"/>
+                        </a:solidFill>
+                        <a:latin typeface="Arial"/>
+                      </a:endParaRPr>
                     </a:p>
                   </a:txBody>
-                  <a:tcPr marL="73152" marR="73152" marT="27432" marB="27432" anchor="t">
+                  <a:tcPr marL="73152" marR="73152" marT="36576" marB="36576" anchor="t">
                     <a:solidFill>
                       <a:srgbClr val="FFFFFF"/>
                     </a:solidFill>
@@ -10134,7 +10105,7 @@
                   </a:tcPr>
                 </a:tc>
               </a:tr>
-              <a:tr h="265176">
+              <a:tr h="274320">
                 <a:tc>
                   <a:txBody>
                     <a:bodyPr/>
@@ -10143,7 +10114,7 @@
                       <a:r>
                         <a:rPr sz="1000" b="1">
                           <a:solidFill>
-                            <a:srgbClr val="15181A"/>
+                            <a:srgbClr val="5B6670"/>
                           </a:solidFill>
                           <a:latin typeface="Arial"/>
                         </a:rPr>
@@ -10151,9 +10122,9 @@
                       </a:r>
                     </a:p>
                   </a:txBody>
-                  <a:tcPr marL="73152" marR="73152" marT="27432" marB="27432" anchor="t">
+                  <a:tcPr marL="73152" marR="73152" marT="36576" marB="36576" anchor="t">
                     <a:solidFill>
-                      <a:srgbClr val="FFFFFF"/>
+                      <a:srgbClr val="F2F5F2"/>
                     </a:solidFill>
                     <a:lnL w="6350" cap="flat" cmpd="sng" algn="ctr">
                       <a:solidFill>
@@ -10186,18 +10157,15 @@
                     <a:bodyPr/>
                     <a:lstStyle/>
                     <a:p>
-                      <a:r>
-                        <a:rPr sz="1000" b="0">
-                          <a:solidFill>
-                            <a:srgbClr val="5B6670"/>
-                          </a:solidFill>
-                          <a:latin typeface="Arial"/>
-                        </a:rPr>
-                        <a:t/>
-                      </a:r>
+                      <a:endParaRPr lang="en-US" sz="1200" b="1">
+                        <a:solidFill>
+                          <a:srgbClr val="15181A"/>
+                        </a:solidFill>
+                        <a:latin typeface="Arial"/>
+                      </a:endParaRPr>
                     </a:p>
                   </a:txBody>
-                  <a:tcPr marL="73152" marR="73152" marT="27432" marB="27432" anchor="t">
+                  <a:tcPr marL="73152" marR="73152" marT="36576" marB="36576" anchor="t">
                     <a:solidFill>
                       <a:srgbClr val="FFFFFF"/>
                     </a:solidFill>
@@ -10232,18 +10200,15 @@
                     <a:bodyPr/>
                     <a:lstStyle/>
                     <a:p>
-                      <a:r>
-                        <a:rPr sz="1000" b="0">
-                          <a:solidFill>
-                            <a:srgbClr val="5B6670"/>
-                          </a:solidFill>
-                          <a:latin typeface="Arial"/>
-                        </a:rPr>
-                        <a:t/>
-                      </a:r>
+                      <a:endParaRPr lang="en-US" sz="1200" b="1">
+                        <a:solidFill>
+                          <a:srgbClr val="15181A"/>
+                        </a:solidFill>
+                        <a:latin typeface="Arial"/>
+                      </a:endParaRPr>
                     </a:p>
                   </a:txBody>
-                  <a:tcPr marL="73152" marR="73152" marT="27432" marB="27432" anchor="t">
+                  <a:tcPr marL="73152" marR="73152" marT="36576" marB="36576" anchor="t">
                     <a:solidFill>
                       <a:srgbClr val="FFFFFF"/>
                     </a:solidFill>
@@ -10278,18 +10243,15 @@
                     <a:bodyPr/>
                     <a:lstStyle/>
                     <a:p>
-                      <a:r>
-                        <a:rPr sz="1000" b="0">
-                          <a:solidFill>
-                            <a:srgbClr val="5B6670"/>
-                          </a:solidFill>
-                          <a:latin typeface="Arial"/>
-                        </a:rPr>
-                        <a:t/>
-                      </a:r>
+                      <a:endParaRPr lang="en-US" sz="1200" b="1">
+                        <a:solidFill>
+                          <a:srgbClr val="15181A"/>
+                        </a:solidFill>
+                        <a:latin typeface="Arial"/>
+                      </a:endParaRPr>
                     </a:p>
                   </a:txBody>
-                  <a:tcPr marL="73152" marR="73152" marT="27432" marB="27432" anchor="t">
+                  <a:tcPr marL="73152" marR="73152" marT="36576" marB="36576" anchor="t">
                     <a:solidFill>
                       <a:srgbClr val="FFFFFF"/>
                     </a:solidFill>
@@ -10320,7 +10282,7 @@
                   </a:tcPr>
                 </a:tc>
               </a:tr>
-              <a:tr h="265176">
+              <a:tr h="274320">
                 <a:tc>
                   <a:txBody>
                     <a:bodyPr/>
@@ -10329,7 +10291,7 @@
                       <a:r>
                         <a:rPr sz="1000" b="1">
                           <a:solidFill>
-                            <a:srgbClr val="15181A"/>
+                            <a:srgbClr val="5B6670"/>
                           </a:solidFill>
                           <a:latin typeface="Arial"/>
                         </a:rPr>
@@ -10337,9 +10299,9 @@
                       </a:r>
                     </a:p>
                   </a:txBody>
-                  <a:tcPr marL="73152" marR="73152" marT="27432" marB="27432" anchor="t">
+                  <a:tcPr marL="73152" marR="73152" marT="36576" marB="36576" anchor="t">
                     <a:solidFill>
-                      <a:srgbClr val="FFFFFF"/>
+                      <a:srgbClr val="F2F5F2"/>
                     </a:solidFill>
                     <a:lnL w="6350" cap="flat" cmpd="sng" algn="ctr">
                       <a:solidFill>
@@ -10372,18 +10334,15 @@
                     <a:bodyPr/>
                     <a:lstStyle/>
                     <a:p>
-                      <a:r>
-                        <a:rPr sz="1000" b="0">
-                          <a:solidFill>
-                            <a:srgbClr val="5B6670"/>
-                          </a:solidFill>
-                          <a:latin typeface="Arial"/>
-                        </a:rPr>
-                        <a:t/>
-                      </a:r>
+                      <a:endParaRPr lang="en-US" sz="1200" b="1">
+                        <a:solidFill>
+                          <a:srgbClr val="15181A"/>
+                        </a:solidFill>
+                        <a:latin typeface="Arial"/>
+                      </a:endParaRPr>
                     </a:p>
                   </a:txBody>
-                  <a:tcPr marL="73152" marR="73152" marT="27432" marB="27432" anchor="t">
+                  <a:tcPr marL="73152" marR="73152" marT="36576" marB="36576" anchor="t">
                     <a:solidFill>
                       <a:srgbClr val="FFFFFF"/>
                     </a:solidFill>
@@ -10418,18 +10377,15 @@
                     <a:bodyPr/>
                     <a:lstStyle/>
                     <a:p>
-                      <a:r>
-                        <a:rPr sz="1000" b="0">
-                          <a:solidFill>
-                            <a:srgbClr val="5B6670"/>
-                          </a:solidFill>
-                          <a:latin typeface="Arial"/>
-                        </a:rPr>
-                        <a:t/>
-                      </a:r>
+                      <a:endParaRPr lang="en-US" sz="1200" b="1">
+                        <a:solidFill>
+                          <a:srgbClr val="15181A"/>
+                        </a:solidFill>
+                        <a:latin typeface="Arial"/>
+                      </a:endParaRPr>
                     </a:p>
                   </a:txBody>
-                  <a:tcPr marL="73152" marR="73152" marT="27432" marB="27432" anchor="t">
+                  <a:tcPr marL="73152" marR="73152" marT="36576" marB="36576" anchor="t">
                     <a:solidFill>
                       <a:srgbClr val="FFFFFF"/>
                     </a:solidFill>
@@ -10464,18 +10420,15 @@
                     <a:bodyPr/>
                     <a:lstStyle/>
                     <a:p>
-                      <a:r>
-                        <a:rPr sz="1000" b="0">
-                          <a:solidFill>
-                            <a:srgbClr val="5B6670"/>
-                          </a:solidFill>
-                          <a:latin typeface="Arial"/>
-                        </a:rPr>
-                        <a:t/>
-                      </a:r>
+                      <a:endParaRPr lang="en-US" sz="1200" b="1">
+                        <a:solidFill>
+                          <a:srgbClr val="15181A"/>
+                        </a:solidFill>
+                        <a:latin typeface="Arial"/>
+                      </a:endParaRPr>
                     </a:p>
                   </a:txBody>
-                  <a:tcPr marL="73152" marR="73152" marT="27432" marB="27432" anchor="t">
+                  <a:tcPr marL="73152" marR="73152" marT="36576" marB="36576" anchor="t">
                     <a:solidFill>
                       <a:srgbClr val="FFFFFF"/>
                     </a:solidFill>
@@ -10506,7 +10459,7 @@
                   </a:tcPr>
                 </a:tc>
               </a:tr>
-              <a:tr h="265176">
+              <a:tr h="274320">
                 <a:tc>
                   <a:txBody>
                     <a:bodyPr/>
@@ -10515,7 +10468,7 @@
                       <a:r>
                         <a:rPr sz="1000" b="1">
                           <a:solidFill>
-                            <a:srgbClr val="15181A"/>
+                            <a:srgbClr val="5B6670"/>
                           </a:solidFill>
                           <a:latin typeface="Arial"/>
                         </a:rPr>
@@ -10523,9 +10476,9 @@
                       </a:r>
                     </a:p>
                   </a:txBody>
-                  <a:tcPr marL="73152" marR="73152" marT="27432" marB="27432" anchor="t">
+                  <a:tcPr marL="73152" marR="73152" marT="36576" marB="36576" anchor="t">
                     <a:solidFill>
-                      <a:srgbClr val="FFFFFF"/>
+                      <a:srgbClr val="F2F5F2"/>
                     </a:solidFill>
                     <a:lnL w="6350" cap="flat" cmpd="sng" algn="ctr">
                       <a:solidFill>
@@ -10558,18 +10511,15 @@
                     <a:bodyPr/>
                     <a:lstStyle/>
                     <a:p>
-                      <a:r>
-                        <a:rPr sz="1000" b="0">
-                          <a:solidFill>
-                            <a:srgbClr val="5B6670"/>
-                          </a:solidFill>
-                          <a:latin typeface="Arial"/>
-                        </a:rPr>
-                        <a:t/>
-                      </a:r>
+                      <a:endParaRPr lang="en-US" sz="1200" b="1">
+                        <a:solidFill>
+                          <a:srgbClr val="15181A"/>
+                        </a:solidFill>
+                        <a:latin typeface="Arial"/>
+                      </a:endParaRPr>
                     </a:p>
                   </a:txBody>
-                  <a:tcPr marL="73152" marR="73152" marT="27432" marB="27432" anchor="t">
+                  <a:tcPr marL="73152" marR="73152" marT="36576" marB="36576" anchor="t">
                     <a:solidFill>
                       <a:srgbClr val="FFFFFF"/>
                     </a:solidFill>
@@ -10604,18 +10554,15 @@
                     <a:bodyPr/>
                     <a:lstStyle/>
                     <a:p>
-                      <a:r>
-                        <a:rPr sz="1000" b="0">
-                          <a:solidFill>
-                            <a:srgbClr val="5B6670"/>
-                          </a:solidFill>
-                          <a:latin typeface="Arial"/>
-                        </a:rPr>
-                        <a:t/>
-                      </a:r>
+                      <a:endParaRPr lang="en-US" sz="1200" b="1">
+                        <a:solidFill>
+                          <a:srgbClr val="15181A"/>
+                        </a:solidFill>
+                        <a:latin typeface="Arial"/>
+                      </a:endParaRPr>
                     </a:p>
                   </a:txBody>
-                  <a:tcPr marL="73152" marR="73152" marT="27432" marB="27432" anchor="t">
+                  <a:tcPr marL="73152" marR="73152" marT="36576" marB="36576" anchor="t">
                     <a:solidFill>
                       <a:srgbClr val="FFFFFF"/>
                     </a:solidFill>
@@ -10650,18 +10597,15 @@
                     <a:bodyPr/>
                     <a:lstStyle/>
                     <a:p>
-                      <a:r>
-                        <a:rPr sz="1000" b="0">
-                          <a:solidFill>
-                            <a:srgbClr val="5B6670"/>
-                          </a:solidFill>
-                          <a:latin typeface="Arial"/>
-                        </a:rPr>
-                        <a:t/>
-                      </a:r>
+                      <a:endParaRPr lang="en-US" sz="1200" b="1">
+                        <a:solidFill>
+                          <a:srgbClr val="15181A"/>
+                        </a:solidFill>
+                        <a:latin typeface="Arial"/>
+                      </a:endParaRPr>
                     </a:p>
                   </a:txBody>
-                  <a:tcPr marL="73152" marR="73152" marT="27432" marB="27432" anchor="t">
+                  <a:tcPr marL="73152" marR="73152" marT="36576" marB="36576" anchor="t">
                     <a:solidFill>
                       <a:srgbClr val="FFFFFF"/>
                     </a:solidFill>
@@ -10692,7 +10636,7 @@
                   </a:tcPr>
                 </a:tc>
               </a:tr>
-              <a:tr h="265176">
+              <a:tr h="274320">
                 <a:tc>
                   <a:txBody>
                     <a:bodyPr/>
@@ -10701,7 +10645,7 @@
                       <a:r>
                         <a:rPr sz="1000" b="1">
                           <a:solidFill>
-                            <a:srgbClr val="15181A"/>
+                            <a:srgbClr val="5B6670"/>
                           </a:solidFill>
                           <a:latin typeface="Arial"/>
                         </a:rPr>
@@ -10709,9 +10653,9 @@
                       </a:r>
                     </a:p>
                   </a:txBody>
-                  <a:tcPr marL="73152" marR="73152" marT="27432" marB="27432" anchor="t">
+                  <a:tcPr marL="73152" marR="73152" marT="36576" marB="36576" anchor="t">
                     <a:solidFill>
-                      <a:srgbClr val="FFFFFF"/>
+                      <a:srgbClr val="F2F5F2"/>
                     </a:solidFill>
                     <a:lnL w="6350" cap="flat" cmpd="sng" algn="ctr">
                       <a:solidFill>
@@ -10744,18 +10688,15 @@
                     <a:bodyPr/>
                     <a:lstStyle/>
                     <a:p>
-                      <a:r>
-                        <a:rPr sz="1000" b="0">
-                          <a:solidFill>
-                            <a:srgbClr val="5B6670"/>
-                          </a:solidFill>
-                          <a:latin typeface="Arial"/>
-                        </a:rPr>
-                        <a:t/>
-                      </a:r>
+                      <a:endParaRPr lang="en-US" sz="1200" b="1">
+                        <a:solidFill>
+                          <a:srgbClr val="15181A"/>
+                        </a:solidFill>
+                        <a:latin typeface="Arial"/>
+                      </a:endParaRPr>
                     </a:p>
                   </a:txBody>
-                  <a:tcPr marL="73152" marR="73152" marT="27432" marB="27432" anchor="t">
+                  <a:tcPr marL="73152" marR="73152" marT="36576" marB="36576" anchor="t">
                     <a:solidFill>
                       <a:srgbClr val="FFFFFF"/>
                     </a:solidFill>
@@ -10790,18 +10731,15 @@
                     <a:bodyPr/>
                     <a:lstStyle/>
                     <a:p>
-                      <a:r>
-                        <a:rPr sz="1000" b="0">
-                          <a:solidFill>
-                            <a:srgbClr val="5B6670"/>
-                          </a:solidFill>
-                          <a:latin typeface="Arial"/>
-                        </a:rPr>
-                        <a:t/>
-                      </a:r>
+                      <a:endParaRPr lang="en-US" sz="1200" b="1">
+                        <a:solidFill>
+                          <a:srgbClr val="15181A"/>
+                        </a:solidFill>
+                        <a:latin typeface="Arial"/>
+                      </a:endParaRPr>
                     </a:p>
                   </a:txBody>
-                  <a:tcPr marL="73152" marR="73152" marT="27432" marB="27432" anchor="t">
+                  <a:tcPr marL="73152" marR="73152" marT="36576" marB="36576" anchor="t">
                     <a:solidFill>
                       <a:srgbClr val="FFFFFF"/>
                     </a:solidFill>
@@ -10836,18 +10774,15 @@
                     <a:bodyPr/>
                     <a:lstStyle/>
                     <a:p>
-                      <a:r>
-                        <a:rPr sz="1000" b="0">
-                          <a:solidFill>
-                            <a:srgbClr val="5B6670"/>
-                          </a:solidFill>
-                          <a:latin typeface="Arial"/>
-                        </a:rPr>
-                        <a:t/>
-                      </a:r>
+                      <a:endParaRPr lang="en-US" sz="1200" b="1">
+                        <a:solidFill>
+                          <a:srgbClr val="15181A"/>
+                        </a:solidFill>
+                        <a:latin typeface="Arial"/>
+                      </a:endParaRPr>
                     </a:p>
                   </a:txBody>
-                  <a:tcPr marL="73152" marR="73152" marT="27432" marB="27432" anchor="t">
+                  <a:tcPr marL="73152" marR="73152" marT="36576" marB="36576" anchor="t">
                     <a:solidFill>
                       <a:srgbClr val="FFFFFF"/>
                     </a:solidFill>
@@ -10884,35 +10819,109 @@
       </p:graphicFrame>
       <p:sp>
         <p:nvSpPr>
+          <p:cNvPr id="7" name="TextBox 6"/>
+          <p:cNvSpPr txBox="1"/>
+          <p:nvPr/>
+        </p:nvSpPr>
+        <p:spPr>
+          <a:xfrm>
+            <a:off x="731520" y="4370832"/>
+            <a:ext cx="5120640" cy="237744"/>
+          </a:xfrm>
+          <a:prstGeom prst="rect">
+            <a:avLst/>
+          </a:prstGeom>
+          <a:noFill/>
+        </p:spPr>
+        <p:txBody>
+          <a:bodyPr wrap="square" lIns="0" rIns="0" tIns="0" bIns="0">
+            <a:noAutofit/>
+          </a:bodyPr>
+          <a:lstStyle/>
+          <a:p>
+            <a:pPr algn="l"/>
+            <a:r>
+              <a:rPr sz="1100" b="1" i="0">
+                <a:solidFill>
+                  <a:srgbClr val="3C7D4D"/>
+                </a:solidFill>
+                <a:latin typeface="Arial"/>
+              </a:rPr>
+              <a:t>WHAT THE NUMBERS DON'T SHOW</a:t>
+            </a:r>
+          </a:p>
+        </p:txBody>
+      </p:sp>
+      <p:sp>
+        <p:nvSpPr>
+          <p:cNvPr id="8" name="TextBox 7"/>
+          <p:cNvSpPr txBox="1"/>
+          <p:nvPr/>
+        </p:nvSpPr>
+        <p:spPr>
+          <a:xfrm>
+            <a:off x="731520" y="4590288"/>
+            <a:ext cx="5120640" cy="237744"/>
+          </a:xfrm>
+          <a:prstGeom prst="rect">
+            <a:avLst/>
+          </a:prstGeom>
+          <a:noFill/>
+        </p:spPr>
+        <p:txBody>
+          <a:bodyPr wrap="square" lIns="0" rIns="0" tIns="0" bIns="0">
+            <a:noAutofit/>
+          </a:bodyPr>
+          <a:lstStyle/>
+          <a:p>
+            <a:pPr algn="l"/>
+            <a:r>
+              <a:rPr sz="1000" b="0" i="0">
+                <a:solidFill>
+                  <a:srgbClr val="5B6670"/>
+                </a:solidFill>
+                <a:latin typeface="Arial"/>
+              </a:rPr>
+              <a:t>Two sentences. Yours.</a:t>
+            </a:r>
+          </a:p>
+        </p:txBody>
+      </p:sp>
+      <p:sp>
+        <p:nvSpPr>
           <p:cNvPr id="9" name="TextBox 8"/>
           <p:cNvSpPr txBox="1"/>
           <p:nvPr/>
         </p:nvSpPr>
         <p:spPr>
           <a:xfrm>
-            <a:off x="731520" y="4389120"/>
-            <a:ext cx="5120640" cy="237744"/>
-          </a:xfrm>
-          <a:prstGeom prst="rect">
-            <a:avLst/>
-          </a:prstGeom>
-          <a:noFill/>
-        </p:spPr>
-        <p:txBody>
-          <a:bodyPr wrap="square" anchor="t" lIns="0" rIns="0" tIns="0" bIns="0">
+            <a:off x="731520" y="4828032"/>
+            <a:ext cx="5120640" cy="1207008"/>
+          </a:xfrm>
+          <a:prstGeom prst="rect">
+            <a:avLst/>
+          </a:prstGeom>
+          <a:solidFill>
+            <a:srgbClr val="FFFFFF"/>
+          </a:solidFill>
+          <a:ln w="9525">
+            <a:solidFill>
+              <a:srgbClr val="E2E6E3"/>
+            </a:solidFill>
+          </a:ln>
+        </p:spPr>
+        <p:txBody>
+          <a:bodyPr wrap="square" tIns="73152" bIns="73152">
             <a:noAutofit/>
           </a:bodyPr>
           <a:lstStyle/>
           <a:p>
-            <a:r>
-              <a:rPr sz="1100" b="1">
-                <a:solidFill>
-                  <a:srgbClr val="3C7D4D"/>
-                </a:solidFill>
-                <a:latin typeface="Arial"/>
-              </a:rPr>
-              <a:t>WHAT THE NUMBERS DON'T SHOW  ·  TWO SENTENCES, YOURS</a:t>
-            </a:r>
+            <a:endParaRPr lang="en-US" sz="1200" b="1">
+              <a:solidFill>
+                <a:srgbClr val="15181A"/>
+              </a:solidFill>
+              <a:latin typeface="Arial"/>
+            </a:endParaRPr>
           </a:p>
         </p:txBody>
       </p:sp>
@@ -10924,71 +10933,36 @@
         </p:nvSpPr>
         <p:spPr>
           <a:xfrm>
-            <a:off x="731520" y="4645152"/>
-            <a:ext cx="5120640" cy="1389888"/>
-          </a:xfrm>
-          <a:prstGeom prst="rect">
-            <a:avLst/>
-          </a:prstGeom>
-          <a:solidFill>
-            <a:srgbClr val="F2F5F2"/>
-          </a:solidFill>
-        </p:spPr>
-        <p:txBody>
-          <a:bodyPr wrap="square" anchor="t" tIns="54864" bIns="54864">
+            <a:off x="6519672" y="2121408"/>
+            <a:ext cx="4937760" cy="237744"/>
+          </a:xfrm>
+          <a:prstGeom prst="rect">
+            <a:avLst/>
+          </a:prstGeom>
+          <a:noFill/>
+        </p:spPr>
+        <p:txBody>
+          <a:bodyPr wrap="square" lIns="0" rIns="0" tIns="0" bIns="0">
             <a:noAutofit/>
           </a:bodyPr>
           <a:lstStyle/>
           <a:p>
-            <a:r>
-              <a:rPr sz="1200" b="0">
-                <a:solidFill>
-                  <a:srgbClr val="5B6670"/>
+            <a:pPr algn="l"/>
+            <a:r>
+              <a:rPr sz="1100" b="1" i="0">
+                <a:solidFill>
+                  <a:srgbClr val="3C7D4D"/>
                 </a:solidFill>
                 <a:latin typeface="Arial"/>
               </a:rPr>
-              <a:t>[Two sentences.]</a:t>
-            </a:r>
-          </a:p>
-        </p:txBody>
-      </p:sp>
-      <p:sp>
-        <p:nvSpPr>
-          <p:cNvPr id="11" name="TextBox 10"/>
-          <p:cNvSpPr txBox="1"/>
-          <p:nvPr/>
-        </p:nvSpPr>
-        <p:spPr>
-          <a:xfrm>
-            <a:off x="6519672" y="2121408"/>
-            <a:ext cx="4937760" cy="237744"/>
-          </a:xfrm>
-          <a:prstGeom prst="rect">
-            <a:avLst/>
-          </a:prstGeom>
-          <a:noFill/>
-        </p:spPr>
-        <p:txBody>
-          <a:bodyPr wrap="square" anchor="t" lIns="0" rIns="0" tIns="0" bIns="0">
-            <a:noAutofit/>
-          </a:bodyPr>
-          <a:lstStyle/>
-          <a:p>
-            <a:r>
-              <a:rPr sz="1100" b="1">
-                <a:solidFill>
-                  <a:srgbClr val="3C7D4D"/>
-                </a:solidFill>
-                <a:latin typeface="Arial"/>
-              </a:rPr>
-              <a:t>TOP ACCOUNTS, YTD BOOKINGS  ·  PRE-FILLED</a:t>
+              <a:t>TOP ACCOUNTS, YTD BOOKINGS</a:t>
             </a:r>
           </a:p>
         </p:txBody>
       </p:sp>
       <p:graphicFrame>
         <p:nvGraphicFramePr>
-          <p:cNvPr id="12" name="Table 11"/>
+          <p:cNvPr id="11" name="Table 10"/>
           <p:cNvGraphicFramePr>
             <a:graphicFrameLocks noGrp="1"/>
           </p:cNvGraphicFramePr>
@@ -10996,7 +10970,7 @@
         </p:nvGraphicFramePr>
         <p:xfrm>
           <a:off x="6519672" y="2377440"/>
-          <a:ext cx="4937760" cy="2130552"/>
+          <a:ext cx="4937760" cy="2212848"/>
         </p:xfrm>
         <a:graphic>
           <a:graphicData uri="http://schemas.openxmlformats.org/drawingml/2006/table">
@@ -11006,7 +10980,7 @@
                 <a:gridCol w="3108960"/>
                 <a:gridCol w="1828800"/>
               </a:tblGrid>
-              <a:tr h="274320">
+              <a:tr h="292608">
                 <a:tc>
                   <a:txBody>
                     <a:bodyPr/>
@@ -11100,24 +11074,21 @@
                   </a:tcPr>
                 </a:tc>
               </a:tr>
-              <a:tr h="265176">
+              <a:tr h="274320">
                 <a:tc>
                   <a:txBody>
                     <a:bodyPr/>
                     <a:lstStyle/>
                     <a:p>
-                      <a:r>
-                        <a:rPr sz="1000" b="1">
-                          <a:solidFill>
-                            <a:srgbClr val="15181A"/>
-                          </a:solidFill>
-                          <a:latin typeface="Arial"/>
-                        </a:rPr>
-                        <a:t>1.  </a:t>
-                      </a:r>
+                      <a:endParaRPr lang="en-US" sz="1200" b="1">
+                        <a:solidFill>
+                          <a:srgbClr val="15181A"/>
+                        </a:solidFill>
+                        <a:latin typeface="Arial"/>
+                      </a:endParaRPr>
                     </a:p>
                   </a:txBody>
-                  <a:tcPr marL="73152" marR="73152" marT="27432" marB="27432" anchor="t">
+                  <a:tcPr marL="73152" marR="73152" marT="36576" marB="36576" anchor="t">
                     <a:solidFill>
                       <a:srgbClr val="FFFFFF"/>
                     </a:solidFill>
@@ -11152,18 +11123,15 @@
                     <a:bodyPr/>
                     <a:lstStyle/>
                     <a:p>
-                      <a:r>
-                        <a:rPr sz="1000" b="0">
-                          <a:solidFill>
-                            <a:srgbClr val="5B6670"/>
-                          </a:solidFill>
-                          <a:latin typeface="Arial"/>
-                        </a:rPr>
-                        <a:t/>
-                      </a:r>
+                      <a:endParaRPr lang="en-US" sz="1200" b="1">
+                        <a:solidFill>
+                          <a:srgbClr val="15181A"/>
+                        </a:solidFill>
+                        <a:latin typeface="Arial"/>
+                      </a:endParaRPr>
                     </a:p>
                   </a:txBody>
-                  <a:tcPr marL="73152" marR="73152" marT="27432" marB="27432" anchor="t">
+                  <a:tcPr marL="73152" marR="73152" marT="36576" marB="36576" anchor="t">
                     <a:solidFill>
                       <a:srgbClr val="FFFFFF"/>
                     </a:solidFill>
@@ -11194,24 +11162,21 @@
                   </a:tcPr>
                 </a:tc>
               </a:tr>
-              <a:tr h="265176">
+              <a:tr h="274320">
                 <a:tc>
                   <a:txBody>
                     <a:bodyPr/>
                     <a:lstStyle/>
                     <a:p>
-                      <a:r>
-                        <a:rPr sz="1000" b="1">
-                          <a:solidFill>
-                            <a:srgbClr val="15181A"/>
-                          </a:solidFill>
-                          <a:latin typeface="Arial"/>
-                        </a:rPr>
-                        <a:t>2.  </a:t>
-                      </a:r>
+                      <a:endParaRPr lang="en-US" sz="1200" b="1">
+                        <a:solidFill>
+                          <a:srgbClr val="15181A"/>
+                        </a:solidFill>
+                        <a:latin typeface="Arial"/>
+                      </a:endParaRPr>
                     </a:p>
                   </a:txBody>
-                  <a:tcPr marL="73152" marR="73152" marT="27432" marB="27432" anchor="t">
+                  <a:tcPr marL="73152" marR="73152" marT="36576" marB="36576" anchor="t">
                     <a:solidFill>
                       <a:srgbClr val="FFFFFF"/>
                     </a:solidFill>
@@ -11246,18 +11211,15 @@
                     <a:bodyPr/>
                     <a:lstStyle/>
                     <a:p>
-                      <a:r>
-                        <a:rPr sz="1000" b="0">
-                          <a:solidFill>
-                            <a:srgbClr val="5B6670"/>
-                          </a:solidFill>
-                          <a:latin typeface="Arial"/>
-                        </a:rPr>
-                        <a:t/>
-                      </a:r>
+                      <a:endParaRPr lang="en-US" sz="1200" b="1">
+                        <a:solidFill>
+                          <a:srgbClr val="15181A"/>
+                        </a:solidFill>
+                        <a:latin typeface="Arial"/>
+                      </a:endParaRPr>
                     </a:p>
                   </a:txBody>
-                  <a:tcPr marL="73152" marR="73152" marT="27432" marB="27432" anchor="t">
+                  <a:tcPr marL="73152" marR="73152" marT="36576" marB="36576" anchor="t">
                     <a:solidFill>
                       <a:srgbClr val="FFFFFF"/>
                     </a:solidFill>
@@ -11288,24 +11250,21 @@
                   </a:tcPr>
                 </a:tc>
               </a:tr>
-              <a:tr h="265176">
+              <a:tr h="274320">
                 <a:tc>
                   <a:txBody>
                     <a:bodyPr/>
                     <a:lstStyle/>
                     <a:p>
-                      <a:r>
-                        <a:rPr sz="1000" b="1">
-                          <a:solidFill>
-                            <a:srgbClr val="15181A"/>
-                          </a:solidFill>
-                          <a:latin typeface="Arial"/>
-                        </a:rPr>
-                        <a:t>3.  </a:t>
-                      </a:r>
+                      <a:endParaRPr lang="en-US" sz="1200" b="1">
+                        <a:solidFill>
+                          <a:srgbClr val="15181A"/>
+                        </a:solidFill>
+                        <a:latin typeface="Arial"/>
+                      </a:endParaRPr>
                     </a:p>
                   </a:txBody>
-                  <a:tcPr marL="73152" marR="73152" marT="27432" marB="27432" anchor="t">
+                  <a:tcPr marL="73152" marR="73152" marT="36576" marB="36576" anchor="t">
                     <a:solidFill>
                       <a:srgbClr val="FFFFFF"/>
                     </a:solidFill>
@@ -11340,18 +11299,15 @@
                     <a:bodyPr/>
                     <a:lstStyle/>
                     <a:p>
-                      <a:r>
-                        <a:rPr sz="1000" b="0">
-                          <a:solidFill>
-                            <a:srgbClr val="5B6670"/>
-                          </a:solidFill>
-                          <a:latin typeface="Arial"/>
-                        </a:rPr>
-                        <a:t/>
-                      </a:r>
+                      <a:endParaRPr lang="en-US" sz="1200" b="1">
+                        <a:solidFill>
+                          <a:srgbClr val="15181A"/>
+                        </a:solidFill>
+                        <a:latin typeface="Arial"/>
+                      </a:endParaRPr>
                     </a:p>
                   </a:txBody>
-                  <a:tcPr marL="73152" marR="73152" marT="27432" marB="27432" anchor="t">
+                  <a:tcPr marL="73152" marR="73152" marT="36576" marB="36576" anchor="t">
                     <a:solidFill>
                       <a:srgbClr val="FFFFFF"/>
                     </a:solidFill>
@@ -11382,24 +11338,21 @@
                   </a:tcPr>
                 </a:tc>
               </a:tr>
-              <a:tr h="265176">
+              <a:tr h="274320">
                 <a:tc>
                   <a:txBody>
                     <a:bodyPr/>
                     <a:lstStyle/>
                     <a:p>
-                      <a:r>
-                        <a:rPr sz="1000" b="1">
-                          <a:solidFill>
-                            <a:srgbClr val="15181A"/>
-                          </a:solidFill>
-                          <a:latin typeface="Arial"/>
-                        </a:rPr>
-                        <a:t>4.  </a:t>
-                      </a:r>
+                      <a:endParaRPr lang="en-US" sz="1200" b="1">
+                        <a:solidFill>
+                          <a:srgbClr val="15181A"/>
+                        </a:solidFill>
+                        <a:latin typeface="Arial"/>
+                      </a:endParaRPr>
                     </a:p>
                   </a:txBody>
-                  <a:tcPr marL="73152" marR="73152" marT="27432" marB="27432" anchor="t">
+                  <a:tcPr marL="73152" marR="73152" marT="36576" marB="36576" anchor="t">
                     <a:solidFill>
                       <a:srgbClr val="FFFFFF"/>
                     </a:solidFill>
@@ -11434,18 +11387,15 @@
                     <a:bodyPr/>
                     <a:lstStyle/>
                     <a:p>
-                      <a:r>
-                        <a:rPr sz="1000" b="0">
-                          <a:solidFill>
-                            <a:srgbClr val="5B6670"/>
-                          </a:solidFill>
-                          <a:latin typeface="Arial"/>
-                        </a:rPr>
-                        <a:t/>
-                      </a:r>
+                      <a:endParaRPr lang="en-US" sz="1200" b="1">
+                        <a:solidFill>
+                          <a:srgbClr val="15181A"/>
+                        </a:solidFill>
+                        <a:latin typeface="Arial"/>
+                      </a:endParaRPr>
                     </a:p>
                   </a:txBody>
-                  <a:tcPr marL="73152" marR="73152" marT="27432" marB="27432" anchor="t">
+                  <a:tcPr marL="73152" marR="73152" marT="36576" marB="36576" anchor="t">
                     <a:solidFill>
                       <a:srgbClr val="FFFFFF"/>
                     </a:solidFill>
@@ -11476,24 +11426,21 @@
                   </a:tcPr>
                 </a:tc>
               </a:tr>
-              <a:tr h="265176">
+              <a:tr h="274320">
                 <a:tc>
                   <a:txBody>
                     <a:bodyPr/>
                     <a:lstStyle/>
                     <a:p>
-                      <a:r>
-                        <a:rPr sz="1000" b="1">
-                          <a:solidFill>
-                            <a:srgbClr val="15181A"/>
-                          </a:solidFill>
-                          <a:latin typeface="Arial"/>
-                        </a:rPr>
-                        <a:t>5.  </a:t>
-                      </a:r>
+                      <a:endParaRPr lang="en-US" sz="1200" b="1">
+                        <a:solidFill>
+                          <a:srgbClr val="15181A"/>
+                        </a:solidFill>
+                        <a:latin typeface="Arial"/>
+                      </a:endParaRPr>
                     </a:p>
                   </a:txBody>
-                  <a:tcPr marL="73152" marR="73152" marT="27432" marB="27432" anchor="t">
+                  <a:tcPr marL="73152" marR="73152" marT="36576" marB="36576" anchor="t">
                     <a:solidFill>
                       <a:srgbClr val="FFFFFF"/>
                     </a:solidFill>
@@ -11528,18 +11475,15 @@
                     <a:bodyPr/>
                     <a:lstStyle/>
                     <a:p>
-                      <a:r>
-                        <a:rPr sz="1000" b="0">
-                          <a:solidFill>
-                            <a:srgbClr val="5B6670"/>
-                          </a:solidFill>
-                          <a:latin typeface="Arial"/>
-                        </a:rPr>
-                        <a:t/>
-                      </a:r>
+                      <a:endParaRPr lang="en-US" sz="1200" b="1">
+                        <a:solidFill>
+                          <a:srgbClr val="15181A"/>
+                        </a:solidFill>
+                        <a:latin typeface="Arial"/>
+                      </a:endParaRPr>
                     </a:p>
                   </a:txBody>
-                  <a:tcPr marL="73152" marR="73152" marT="27432" marB="27432" anchor="t">
+                  <a:tcPr marL="73152" marR="73152" marT="36576" marB="36576" anchor="t">
                     <a:solidFill>
                       <a:srgbClr val="FFFFFF"/>
                     </a:solidFill>
@@ -11570,24 +11514,21 @@
                   </a:tcPr>
                 </a:tc>
               </a:tr>
-              <a:tr h="265176">
+              <a:tr h="274320">
                 <a:tc>
                   <a:txBody>
                     <a:bodyPr/>
                     <a:lstStyle/>
                     <a:p>
-                      <a:r>
-                        <a:rPr sz="1000" b="1">
-                          <a:solidFill>
-                            <a:srgbClr val="15181A"/>
-                          </a:solidFill>
-                          <a:latin typeface="Arial"/>
-                        </a:rPr>
-                        <a:t>6.  </a:t>
-                      </a:r>
+                      <a:endParaRPr lang="en-US" sz="1200" b="1">
+                        <a:solidFill>
+                          <a:srgbClr val="15181A"/>
+                        </a:solidFill>
+                        <a:latin typeface="Arial"/>
+                      </a:endParaRPr>
                     </a:p>
                   </a:txBody>
-                  <a:tcPr marL="73152" marR="73152" marT="27432" marB="27432" anchor="t">
+                  <a:tcPr marL="73152" marR="73152" marT="36576" marB="36576" anchor="t">
                     <a:solidFill>
                       <a:srgbClr val="FFFFFF"/>
                     </a:solidFill>
@@ -11622,18 +11563,15 @@
                     <a:bodyPr/>
                     <a:lstStyle/>
                     <a:p>
-                      <a:r>
-                        <a:rPr sz="1000" b="0">
-                          <a:solidFill>
-                            <a:srgbClr val="5B6670"/>
-                          </a:solidFill>
-                          <a:latin typeface="Arial"/>
-                        </a:rPr>
-                        <a:t/>
-                      </a:r>
+                      <a:endParaRPr lang="en-US" sz="1200" b="1">
+                        <a:solidFill>
+                          <a:srgbClr val="15181A"/>
+                        </a:solidFill>
+                        <a:latin typeface="Arial"/>
+                      </a:endParaRPr>
                     </a:p>
                   </a:txBody>
-                  <a:tcPr marL="73152" marR="73152" marT="27432" marB="27432" anchor="t">
+                  <a:tcPr marL="73152" marR="73152" marT="36576" marB="36576" anchor="t">
                     <a:solidFill>
                       <a:srgbClr val="FFFFFF"/>
                     </a:solidFill>
@@ -11664,24 +11602,21 @@
                   </a:tcPr>
                 </a:tc>
               </a:tr>
-              <a:tr h="265176">
+              <a:tr h="274320">
                 <a:tc>
                   <a:txBody>
                     <a:bodyPr/>
                     <a:lstStyle/>
                     <a:p>
-                      <a:r>
-                        <a:rPr sz="1000" b="1">
-                          <a:solidFill>
-                            <a:srgbClr val="15181A"/>
-                          </a:solidFill>
-                          <a:latin typeface="Arial"/>
-                        </a:rPr>
-                        <a:t>7.  </a:t>
-                      </a:r>
+                      <a:endParaRPr lang="en-US" sz="1200" b="1">
+                        <a:solidFill>
+                          <a:srgbClr val="15181A"/>
+                        </a:solidFill>
+                        <a:latin typeface="Arial"/>
+                      </a:endParaRPr>
                     </a:p>
                   </a:txBody>
-                  <a:tcPr marL="73152" marR="73152" marT="27432" marB="27432" anchor="t">
+                  <a:tcPr marL="73152" marR="73152" marT="36576" marB="36576" anchor="t">
                     <a:solidFill>
                       <a:srgbClr val="FFFFFF"/>
                     </a:solidFill>
@@ -11716,18 +11651,15 @@
                     <a:bodyPr/>
                     <a:lstStyle/>
                     <a:p>
-                      <a:r>
-                        <a:rPr sz="1000" b="0">
-                          <a:solidFill>
-                            <a:srgbClr val="5B6670"/>
-                          </a:solidFill>
-                          <a:latin typeface="Arial"/>
-                        </a:rPr>
-                        <a:t/>
-                      </a:r>
+                      <a:endParaRPr lang="en-US" sz="1200" b="1">
+                        <a:solidFill>
+                          <a:srgbClr val="15181A"/>
+                        </a:solidFill>
+                        <a:latin typeface="Arial"/>
+                      </a:endParaRPr>
                     </a:p>
                   </a:txBody>
-                  <a:tcPr marL="73152" marR="73152" marT="27432" marB="27432" anchor="t">
+                  <a:tcPr marL="73152" marR="73152" marT="36576" marB="36576" anchor="t">
                     <a:solidFill>
                       <a:srgbClr val="FFFFFF"/>
                     </a:solidFill>
@@ -11762,6 +11694,41 @@
           </a:graphicData>
         </a:graphic>
       </p:graphicFrame>
+      <p:sp>
+        <p:nvSpPr>
+          <p:cNvPr id="12" name="TextBox 11"/>
+          <p:cNvSpPr txBox="1"/>
+          <p:nvPr/>
+        </p:nvSpPr>
+        <p:spPr>
+          <a:xfrm>
+            <a:off x="731520" y="6364224"/>
+            <a:ext cx="7863840" cy="237744"/>
+          </a:xfrm>
+          <a:prstGeom prst="rect">
+            <a:avLst/>
+          </a:prstGeom>
+          <a:noFill/>
+        </p:spPr>
+        <p:txBody>
+          <a:bodyPr wrap="square" lIns="0" rIns="0" tIns="0" bIns="0">
+            <a:noAutofit/>
+          </a:bodyPr>
+          <a:lstStyle/>
+          <a:p>
+            <a:pPr algn="l"/>
+            <a:r>
+              <a:rPr sz="900" b="0" i="0">
+                <a:solidFill>
+                  <a:srgbClr val="5B6670"/>
+                </a:solidFill>
+                <a:latin typeface="Arial"/>
+              </a:rPr>
+              <a:t>Source: [system], pulled [date]. Quotes are a count. Pre-filled by Nate.</a:t>
+            </a:r>
+          </a:p>
+        </p:txBody>
+      </p:sp>
     </p:spTree>
   </p:cSld>
   <p:clrMapOvr>
@@ -11838,7 +11805,7 @@
           <a:lstStyle/>
           <a:p>
             <a:r>
-              <a:t>[One line. The product and account pattern that's working.]</a:t>
+              <a:t>Which products are winning with which accounts, and where the biggest new customer opportunities are.</a:t>
             </a:r>
           </a:p>
         </p:txBody>
@@ -11860,13 +11827,14 @@
           <a:noFill/>
         </p:spPr>
         <p:txBody>
-          <a:bodyPr wrap="square" anchor="t" lIns="0" rIns="0" tIns="0" bIns="0">
+          <a:bodyPr wrap="square" lIns="0" rIns="0" tIns="0" bIns="0">
             <a:noAutofit/>
           </a:bodyPr>
           <a:lstStyle/>
           <a:p>
-            <a:r>
-              <a:rPr sz="1100" b="1">
+            <a:pPr algn="l"/>
+            <a:r>
+              <a:rPr sz="1100" b="1" i="0">
                 <a:solidFill>
                   <a:srgbClr val="3C7D4D"/>
                 </a:solidFill>
@@ -11887,25 +11855,25 @@
         </p:nvGraphicFramePr>
         <p:xfrm>
           <a:off x="731520" y="2377440"/>
-          <a:ext cx="5120640" cy="3383280"/>
+          <a:ext cx="5120640" cy="3209544"/>
         </p:xfrm>
         <a:graphic>
           <a:graphicData uri="http://schemas.openxmlformats.org/drawingml/2006/table">
             <a:tbl>
               <a:tblPr firstRow="0" bandRow="0"/>
               <a:tblGrid>
-                <a:gridCol w="1645920"/>
-                <a:gridCol w="1645920"/>
-                <a:gridCol w="1828800"/>
+                <a:gridCol w="1554480"/>
+                <a:gridCol w="1554480"/>
+                <a:gridCol w="2011680"/>
               </a:tblGrid>
-              <a:tr h="365760">
+              <a:tr h="329184">
                 <a:tc>
                   <a:txBody>
                     <a:bodyPr/>
                     <a:lstStyle/>
                     <a:p>
                       <a:r>
-                        <a:rPr sz="1100" b="1">
+                        <a:rPr sz="1000" b="1">
                           <a:solidFill>
                             <a:srgbClr val="FFFFFF"/>
                           </a:solidFill>
@@ -11951,7 +11919,7 @@
                     <a:lstStyle/>
                     <a:p>
                       <a:r>
-                        <a:rPr sz="1100" b="1">
+                        <a:rPr sz="1000" b="1">
                           <a:solidFill>
                             <a:srgbClr val="FFFFFF"/>
                           </a:solidFill>
@@ -11997,7 +11965,7 @@
                     <a:lstStyle/>
                     <a:p>
                       <a:r>
-                        <a:rPr sz="1100" b="1">
+                        <a:rPr sz="1000" b="1">
                           <a:solidFill>
                             <a:srgbClr val="FFFFFF"/>
                           </a:solidFill>
@@ -12038,24 +12006,21 @@
                   </a:tcPr>
                 </a:tc>
               </a:tr>
-              <a:tr h="1005840">
+              <a:tr h="960120">
                 <a:tc>
                   <a:txBody>
                     <a:bodyPr/>
                     <a:lstStyle/>
                     <a:p>
-                      <a:r>
-                        <a:rPr sz="1100" b="1">
-                          <a:solidFill>
-                            <a:srgbClr val="15181A"/>
-                          </a:solidFill>
-                          <a:latin typeface="Arial"/>
-                        </a:rPr>
-                        <a:t>1.  </a:t>
-                      </a:r>
+                      <a:endParaRPr lang="en-US" sz="1200" b="1">
+                        <a:solidFill>
+                          <a:srgbClr val="15181A"/>
+                        </a:solidFill>
+                        <a:latin typeface="Arial"/>
+                      </a:endParaRPr>
                     </a:p>
                   </a:txBody>
-                  <a:tcPr marL="73152" marR="73152" marT="27432" marB="27432" anchor="t">
+                  <a:tcPr marL="73152" marR="73152" marT="36576" marB="36576" anchor="t">
                     <a:solidFill>
                       <a:srgbClr val="FFFFFF"/>
                     </a:solidFill>
@@ -12090,18 +12055,15 @@
                     <a:bodyPr/>
                     <a:lstStyle/>
                     <a:p>
-                      <a:r>
-                        <a:rPr sz="1100" b="0">
-                          <a:solidFill>
-                            <a:srgbClr val="5B6670"/>
-                          </a:solidFill>
-                          <a:latin typeface="Arial"/>
-                        </a:rPr>
-                        <a:t/>
-                      </a:r>
+                      <a:endParaRPr lang="en-US" sz="1200" b="1">
+                        <a:solidFill>
+                          <a:srgbClr val="15181A"/>
+                        </a:solidFill>
+                        <a:latin typeface="Arial"/>
+                      </a:endParaRPr>
                     </a:p>
                   </a:txBody>
-                  <a:tcPr marL="73152" marR="73152" marT="27432" marB="27432" anchor="t">
+                  <a:tcPr marL="73152" marR="73152" marT="36576" marB="36576" anchor="t">
                     <a:solidFill>
                       <a:srgbClr val="FFFFFF"/>
                     </a:solidFill>
@@ -12136,18 +12098,15 @@
                     <a:bodyPr/>
                     <a:lstStyle/>
                     <a:p>
-                      <a:r>
-                        <a:rPr sz="1100" b="0">
-                          <a:solidFill>
-                            <a:srgbClr val="5B6670"/>
-                          </a:solidFill>
-                          <a:latin typeface="Arial"/>
-                        </a:rPr>
-                        <a:t/>
-                      </a:r>
+                      <a:endParaRPr lang="en-US" sz="1200" b="1">
+                        <a:solidFill>
+                          <a:srgbClr val="15181A"/>
+                        </a:solidFill>
+                        <a:latin typeface="Arial"/>
+                      </a:endParaRPr>
                     </a:p>
                   </a:txBody>
-                  <a:tcPr marL="73152" marR="73152" marT="27432" marB="27432" anchor="t">
+                  <a:tcPr marL="73152" marR="73152" marT="36576" marB="36576" anchor="t">
                     <a:solidFill>
                       <a:srgbClr val="FFFFFF"/>
                     </a:solidFill>
@@ -12178,24 +12137,21 @@
                   </a:tcPr>
                 </a:tc>
               </a:tr>
-              <a:tr h="1005840">
+              <a:tr h="960120">
                 <a:tc>
                   <a:txBody>
                     <a:bodyPr/>
                     <a:lstStyle/>
                     <a:p>
-                      <a:r>
-                        <a:rPr sz="1100" b="1">
-                          <a:solidFill>
-                            <a:srgbClr val="15181A"/>
-                          </a:solidFill>
-                          <a:latin typeface="Arial"/>
-                        </a:rPr>
-                        <a:t>2.  </a:t>
-                      </a:r>
+                      <a:endParaRPr lang="en-US" sz="1200" b="1">
+                        <a:solidFill>
+                          <a:srgbClr val="15181A"/>
+                        </a:solidFill>
+                        <a:latin typeface="Arial"/>
+                      </a:endParaRPr>
                     </a:p>
                   </a:txBody>
-                  <a:tcPr marL="73152" marR="73152" marT="27432" marB="27432" anchor="t">
+                  <a:tcPr marL="73152" marR="73152" marT="36576" marB="36576" anchor="t">
                     <a:solidFill>
                       <a:srgbClr val="FFFFFF"/>
                     </a:solidFill>
@@ -12230,18 +12186,15 @@
                     <a:bodyPr/>
                     <a:lstStyle/>
                     <a:p>
-                      <a:r>
-                        <a:rPr sz="1100" b="0">
-                          <a:solidFill>
-                            <a:srgbClr val="5B6670"/>
-                          </a:solidFill>
-                          <a:latin typeface="Arial"/>
-                        </a:rPr>
-                        <a:t/>
-                      </a:r>
+                      <a:endParaRPr lang="en-US" sz="1200" b="1">
+                        <a:solidFill>
+                          <a:srgbClr val="15181A"/>
+                        </a:solidFill>
+                        <a:latin typeface="Arial"/>
+                      </a:endParaRPr>
                     </a:p>
                   </a:txBody>
-                  <a:tcPr marL="73152" marR="73152" marT="27432" marB="27432" anchor="t">
+                  <a:tcPr marL="73152" marR="73152" marT="36576" marB="36576" anchor="t">
                     <a:solidFill>
                       <a:srgbClr val="FFFFFF"/>
                     </a:solidFill>
@@ -12276,18 +12229,15 @@
                     <a:bodyPr/>
                     <a:lstStyle/>
                     <a:p>
-                      <a:r>
-                        <a:rPr sz="1100" b="0">
-                          <a:solidFill>
-                            <a:srgbClr val="5B6670"/>
-                          </a:solidFill>
-                          <a:latin typeface="Arial"/>
-                        </a:rPr>
-                        <a:t/>
-                      </a:r>
+                      <a:endParaRPr lang="en-US" sz="1200" b="1">
+                        <a:solidFill>
+                          <a:srgbClr val="15181A"/>
+                        </a:solidFill>
+                        <a:latin typeface="Arial"/>
+                      </a:endParaRPr>
                     </a:p>
                   </a:txBody>
-                  <a:tcPr marL="73152" marR="73152" marT="27432" marB="27432" anchor="t">
+                  <a:tcPr marL="73152" marR="73152" marT="36576" marB="36576" anchor="t">
                     <a:solidFill>
                       <a:srgbClr val="FFFFFF"/>
                     </a:solidFill>
@@ -12318,24 +12268,21 @@
                   </a:tcPr>
                 </a:tc>
               </a:tr>
-              <a:tr h="1005840">
+              <a:tr h="960120">
                 <a:tc>
                   <a:txBody>
                     <a:bodyPr/>
                     <a:lstStyle/>
                     <a:p>
-                      <a:r>
-                        <a:rPr sz="1100" b="1">
-                          <a:solidFill>
-                            <a:srgbClr val="15181A"/>
-                          </a:solidFill>
-                          <a:latin typeface="Arial"/>
-                        </a:rPr>
-                        <a:t>3.  </a:t>
-                      </a:r>
+                      <a:endParaRPr lang="en-US" sz="1200" b="1">
+                        <a:solidFill>
+                          <a:srgbClr val="15181A"/>
+                        </a:solidFill>
+                        <a:latin typeface="Arial"/>
+                      </a:endParaRPr>
                     </a:p>
                   </a:txBody>
-                  <a:tcPr marL="73152" marR="73152" marT="27432" marB="27432" anchor="t">
+                  <a:tcPr marL="73152" marR="73152" marT="36576" marB="36576" anchor="t">
                     <a:solidFill>
                       <a:srgbClr val="FFFFFF"/>
                     </a:solidFill>
@@ -12370,18 +12317,15 @@
                     <a:bodyPr/>
                     <a:lstStyle/>
                     <a:p>
-                      <a:r>
-                        <a:rPr sz="1100" b="0">
-                          <a:solidFill>
-                            <a:srgbClr val="5B6670"/>
-                          </a:solidFill>
-                          <a:latin typeface="Arial"/>
-                        </a:rPr>
-                        <a:t/>
-                      </a:r>
+                      <a:endParaRPr lang="en-US" sz="1200" b="1">
+                        <a:solidFill>
+                          <a:srgbClr val="15181A"/>
+                        </a:solidFill>
+                        <a:latin typeface="Arial"/>
+                      </a:endParaRPr>
                     </a:p>
                   </a:txBody>
-                  <a:tcPr marL="73152" marR="73152" marT="27432" marB="27432" anchor="t">
+                  <a:tcPr marL="73152" marR="73152" marT="36576" marB="36576" anchor="t">
                     <a:solidFill>
                       <a:srgbClr val="FFFFFF"/>
                     </a:solidFill>
@@ -12416,18 +12360,15 @@
                     <a:bodyPr/>
                     <a:lstStyle/>
                     <a:p>
-                      <a:r>
-                        <a:rPr sz="1100" b="0">
-                          <a:solidFill>
-                            <a:srgbClr val="5B6670"/>
-                          </a:solidFill>
-                          <a:latin typeface="Arial"/>
-                        </a:rPr>
-                        <a:t/>
-                      </a:r>
+                      <a:endParaRPr lang="en-US" sz="1200" b="1">
+                        <a:solidFill>
+                          <a:srgbClr val="15181A"/>
+                        </a:solidFill>
+                        <a:latin typeface="Arial"/>
+                      </a:endParaRPr>
                     </a:p>
                   </a:txBody>
-                  <a:tcPr marL="73152" marR="73152" marT="27432" marB="27432" anchor="t">
+                  <a:tcPr marL="73152" marR="73152" marT="36576" marB="36576" anchor="t">
                     <a:solidFill>
                       <a:srgbClr val="FFFFFF"/>
                     </a:solidFill>
@@ -12479,13 +12420,14 @@
           <a:noFill/>
         </p:spPr>
         <p:txBody>
-          <a:bodyPr wrap="square" anchor="t" lIns="0" rIns="0" tIns="0" bIns="0">
+          <a:bodyPr wrap="square" lIns="0" rIns="0" tIns="0" bIns="0">
             <a:noAutofit/>
           </a:bodyPr>
           <a:lstStyle/>
           <a:p>
-            <a:r>
-              <a:rPr sz="1100" b="1">
+            <a:pPr algn="l"/>
+            <a:r>
+              <a:rPr sz="1100" b="1" i="0">
                 <a:solidFill>
                   <a:srgbClr val="3C7D4D"/>
                 </a:solidFill>
@@ -12506,25 +12448,25 @@
         </p:nvGraphicFramePr>
         <p:xfrm>
           <a:off x="6519672" y="2377440"/>
-          <a:ext cx="4937760" cy="3383280"/>
+          <a:ext cx="4937760" cy="3209544"/>
         </p:xfrm>
         <a:graphic>
           <a:graphicData uri="http://schemas.openxmlformats.org/drawingml/2006/table">
             <a:tbl>
               <a:tblPr firstRow="0" bandRow="0"/>
               <a:tblGrid>
-                <a:gridCol w="1645920"/>
-                <a:gridCol w="1645920"/>
-                <a:gridCol w="1645920"/>
+                <a:gridCol w="1554480"/>
+                <a:gridCol w="1691640"/>
+                <a:gridCol w="1691640"/>
               </a:tblGrid>
-              <a:tr h="365760">
+              <a:tr h="329184">
                 <a:tc>
                   <a:txBody>
                     <a:bodyPr/>
                     <a:lstStyle/>
                     <a:p>
                       <a:r>
-                        <a:rPr sz="1100" b="1">
+                        <a:rPr sz="1000" b="1">
                           <a:solidFill>
                             <a:srgbClr val="FFFFFF"/>
                           </a:solidFill>
@@ -12570,7 +12512,7 @@
                     <a:lstStyle/>
                     <a:p>
                       <a:r>
-                        <a:rPr sz="1100" b="1">
+                        <a:rPr sz="1000" b="1">
                           <a:solidFill>
                             <a:srgbClr val="FFFFFF"/>
                           </a:solidFill>
@@ -12616,7 +12558,7 @@
                     <a:lstStyle/>
                     <a:p>
                       <a:r>
-                        <a:rPr sz="1100" b="1">
+                        <a:rPr sz="1000" b="1">
                           <a:solidFill>
                             <a:srgbClr val="FFFFFF"/>
                           </a:solidFill>
@@ -12657,24 +12599,21 @@
                   </a:tcPr>
                 </a:tc>
               </a:tr>
-              <a:tr h="1005840">
+              <a:tr h="960120">
                 <a:tc>
                   <a:txBody>
                     <a:bodyPr/>
                     <a:lstStyle/>
                     <a:p>
-                      <a:r>
-                        <a:rPr sz="1100" b="1">
-                          <a:solidFill>
-                            <a:srgbClr val="15181A"/>
-                          </a:solidFill>
-                          <a:latin typeface="Arial"/>
-                        </a:rPr>
-                        <a:t>1.  </a:t>
-                      </a:r>
+                      <a:endParaRPr lang="en-US" sz="1200" b="1">
+                        <a:solidFill>
+                          <a:srgbClr val="15181A"/>
+                        </a:solidFill>
+                        <a:latin typeface="Arial"/>
+                      </a:endParaRPr>
                     </a:p>
                   </a:txBody>
-                  <a:tcPr marL="73152" marR="73152" marT="27432" marB="27432" anchor="t">
+                  <a:tcPr marL="73152" marR="73152" marT="36576" marB="36576" anchor="t">
                     <a:solidFill>
                       <a:srgbClr val="FFFFFF"/>
                     </a:solidFill>
@@ -12709,18 +12648,15 @@
                     <a:bodyPr/>
                     <a:lstStyle/>
                     <a:p>
-                      <a:r>
-                        <a:rPr sz="1100" b="0">
-                          <a:solidFill>
-                            <a:srgbClr val="5B6670"/>
-                          </a:solidFill>
-                          <a:latin typeface="Arial"/>
-                        </a:rPr>
-                        <a:t/>
-                      </a:r>
+                      <a:endParaRPr lang="en-US" sz="1200" b="1">
+                        <a:solidFill>
+                          <a:srgbClr val="15181A"/>
+                        </a:solidFill>
+                        <a:latin typeface="Arial"/>
+                      </a:endParaRPr>
                     </a:p>
                   </a:txBody>
-                  <a:tcPr marL="73152" marR="73152" marT="27432" marB="27432" anchor="t">
+                  <a:tcPr marL="73152" marR="73152" marT="36576" marB="36576" anchor="t">
                     <a:solidFill>
                       <a:srgbClr val="FFFFFF"/>
                     </a:solidFill>
@@ -12755,18 +12691,15 @@
                     <a:bodyPr/>
                     <a:lstStyle/>
                     <a:p>
-                      <a:r>
-                        <a:rPr sz="1100" b="0">
-                          <a:solidFill>
-                            <a:srgbClr val="5B6670"/>
-                          </a:solidFill>
-                          <a:latin typeface="Arial"/>
-                        </a:rPr>
-                        <a:t/>
-                      </a:r>
+                      <a:endParaRPr lang="en-US" sz="1200" b="1">
+                        <a:solidFill>
+                          <a:srgbClr val="15181A"/>
+                        </a:solidFill>
+                        <a:latin typeface="Arial"/>
+                      </a:endParaRPr>
                     </a:p>
                   </a:txBody>
-                  <a:tcPr marL="73152" marR="73152" marT="27432" marB="27432" anchor="t">
+                  <a:tcPr marL="73152" marR="73152" marT="36576" marB="36576" anchor="t">
                     <a:solidFill>
                       <a:srgbClr val="FFFFFF"/>
                     </a:solidFill>
@@ -12797,24 +12730,21 @@
                   </a:tcPr>
                 </a:tc>
               </a:tr>
-              <a:tr h="1005840">
+              <a:tr h="960120">
                 <a:tc>
                   <a:txBody>
                     <a:bodyPr/>
                     <a:lstStyle/>
                     <a:p>
-                      <a:r>
-                        <a:rPr sz="1100" b="1">
-                          <a:solidFill>
-                            <a:srgbClr val="15181A"/>
-                          </a:solidFill>
-                          <a:latin typeface="Arial"/>
-                        </a:rPr>
-                        <a:t>2.  </a:t>
-                      </a:r>
+                      <a:endParaRPr lang="en-US" sz="1200" b="1">
+                        <a:solidFill>
+                          <a:srgbClr val="15181A"/>
+                        </a:solidFill>
+                        <a:latin typeface="Arial"/>
+                      </a:endParaRPr>
                     </a:p>
                   </a:txBody>
-                  <a:tcPr marL="73152" marR="73152" marT="27432" marB="27432" anchor="t">
+                  <a:tcPr marL="73152" marR="73152" marT="36576" marB="36576" anchor="t">
                     <a:solidFill>
                       <a:srgbClr val="FFFFFF"/>
                     </a:solidFill>
@@ -12849,18 +12779,15 @@
                     <a:bodyPr/>
                     <a:lstStyle/>
                     <a:p>
-                      <a:r>
-                        <a:rPr sz="1100" b="0">
-                          <a:solidFill>
-                            <a:srgbClr val="5B6670"/>
-                          </a:solidFill>
-                          <a:latin typeface="Arial"/>
-                        </a:rPr>
-                        <a:t/>
-                      </a:r>
+                      <a:endParaRPr lang="en-US" sz="1200" b="1">
+                        <a:solidFill>
+                          <a:srgbClr val="15181A"/>
+                        </a:solidFill>
+                        <a:latin typeface="Arial"/>
+                      </a:endParaRPr>
                     </a:p>
                   </a:txBody>
-                  <a:tcPr marL="73152" marR="73152" marT="27432" marB="27432" anchor="t">
+                  <a:tcPr marL="73152" marR="73152" marT="36576" marB="36576" anchor="t">
                     <a:solidFill>
                       <a:srgbClr val="FFFFFF"/>
                     </a:solidFill>
@@ -12895,18 +12822,15 @@
                     <a:bodyPr/>
                     <a:lstStyle/>
                     <a:p>
-                      <a:r>
-                        <a:rPr sz="1100" b="0">
-                          <a:solidFill>
-                            <a:srgbClr val="5B6670"/>
-                          </a:solidFill>
-                          <a:latin typeface="Arial"/>
-                        </a:rPr>
-                        <a:t/>
-                      </a:r>
+                      <a:endParaRPr lang="en-US" sz="1200" b="1">
+                        <a:solidFill>
+                          <a:srgbClr val="15181A"/>
+                        </a:solidFill>
+                        <a:latin typeface="Arial"/>
+                      </a:endParaRPr>
                     </a:p>
                   </a:txBody>
-                  <a:tcPr marL="73152" marR="73152" marT="27432" marB="27432" anchor="t">
+                  <a:tcPr marL="73152" marR="73152" marT="36576" marB="36576" anchor="t">
                     <a:solidFill>
                       <a:srgbClr val="FFFFFF"/>
                     </a:solidFill>
@@ -12937,24 +12861,21 @@
                   </a:tcPr>
                 </a:tc>
               </a:tr>
-              <a:tr h="1005840">
+              <a:tr h="960120">
                 <a:tc>
                   <a:txBody>
                     <a:bodyPr/>
                     <a:lstStyle/>
                     <a:p>
-                      <a:r>
-                        <a:rPr sz="1100" b="1">
-                          <a:solidFill>
-                            <a:srgbClr val="15181A"/>
-                          </a:solidFill>
-                          <a:latin typeface="Arial"/>
-                        </a:rPr>
-                        <a:t>3.  </a:t>
-                      </a:r>
+                      <a:endParaRPr lang="en-US" sz="1200" b="1">
+                        <a:solidFill>
+                          <a:srgbClr val="15181A"/>
+                        </a:solidFill>
+                        <a:latin typeface="Arial"/>
+                      </a:endParaRPr>
                     </a:p>
                   </a:txBody>
-                  <a:tcPr marL="73152" marR="73152" marT="27432" marB="27432" anchor="t">
+                  <a:tcPr marL="73152" marR="73152" marT="36576" marB="36576" anchor="t">
                     <a:solidFill>
                       <a:srgbClr val="FFFFFF"/>
                     </a:solidFill>
@@ -12989,18 +12910,15 @@
                     <a:bodyPr/>
                     <a:lstStyle/>
                     <a:p>
-                      <a:r>
-                        <a:rPr sz="1100" b="0">
-                          <a:solidFill>
-                            <a:srgbClr val="5B6670"/>
-                          </a:solidFill>
-                          <a:latin typeface="Arial"/>
-                        </a:rPr>
-                        <a:t/>
-                      </a:r>
+                      <a:endParaRPr lang="en-US" sz="1200" b="1">
+                        <a:solidFill>
+                          <a:srgbClr val="15181A"/>
+                        </a:solidFill>
+                        <a:latin typeface="Arial"/>
+                      </a:endParaRPr>
                     </a:p>
                   </a:txBody>
-                  <a:tcPr marL="73152" marR="73152" marT="27432" marB="27432" anchor="t">
+                  <a:tcPr marL="73152" marR="73152" marT="36576" marB="36576" anchor="t">
                     <a:solidFill>
                       <a:srgbClr val="FFFFFF"/>
                     </a:solidFill>
@@ -13035,18 +12953,15 @@
                     <a:bodyPr/>
                     <a:lstStyle/>
                     <a:p>
-                      <a:r>
-                        <a:rPr sz="1100" b="0">
-                          <a:solidFill>
-                            <a:srgbClr val="5B6670"/>
-                          </a:solidFill>
-                          <a:latin typeface="Arial"/>
-                        </a:rPr>
-                        <a:t/>
-                      </a:r>
+                      <a:endParaRPr lang="en-US" sz="1200" b="1">
+                        <a:solidFill>
+                          <a:srgbClr val="15181A"/>
+                        </a:solidFill>
+                        <a:latin typeface="Arial"/>
+                      </a:endParaRPr>
                     </a:p>
                   </a:txBody>
-                  <a:tcPr marL="73152" marR="73152" marT="27432" marB="27432" anchor="t">
+                  <a:tcPr marL="73152" marR="73152" marT="36576" marB="36576" anchor="t">
                     <a:solidFill>
                       <a:srgbClr val="FFFFFF"/>
                     </a:solidFill>
@@ -13081,6 +12996,41 @@
           </a:graphicData>
         </a:graphic>
       </p:graphicFrame>
+      <p:sp>
+        <p:nvSpPr>
+          <p:cNvPr id="9" name="TextBox 8"/>
+          <p:cNvSpPr txBox="1"/>
+          <p:nvPr/>
+        </p:nvSpPr>
+        <p:spPr>
+          <a:xfrm>
+            <a:off x="731520" y="5797296"/>
+            <a:ext cx="10725912" cy="237744"/>
+          </a:xfrm>
+          <a:prstGeom prst="rect">
+            <a:avLst/>
+          </a:prstGeom>
+          <a:noFill/>
+        </p:spPr>
+        <p:txBody>
+          <a:bodyPr wrap="square" lIns="0" rIns="0" tIns="0" bIns="0">
+            <a:noAutofit/>
+          </a:bodyPr>
+          <a:lstStyle/>
+          <a:p>
+            <a:pPr algn="l"/>
+            <a:r>
+              <a:rPr sz="1100" b="1" i="0">
+                <a:solidFill>
+                  <a:srgbClr val="3C7D4D"/>
+                </a:solidFill>
+                <a:latin typeface="Arial"/>
+              </a:rPr>
+              <a:t>For the room:  Which of these wins could a dealer territory copy?</a:t>
+            </a:r>
+          </a:p>
+        </p:txBody>
+      </p:sp>
     </p:spTree>
   </p:cSld>
   <p:clrMapOvr>
@@ -13157,111 +13107,894 @@
           <a:lstStyle/>
           <a:p>
             <a:r>
-              <a:t>[One line. The thing they count on most, and the gap that costs the most.]</a:t>
-            </a:r>
-          </a:p>
-        </p:txBody>
-      </p:sp>
-      <p:sp>
-        <p:nvSpPr>
-          <p:cNvPr id="5" name="Text Placeholder 4"/>
-          <p:cNvSpPr>
-            <a:spLocks noGrp="1"/>
-          </p:cNvSpPr>
-          <p:nvPr>
-            <p:ph type="body" idx="103"/>
-          </p:nvPr>
-        </p:nvSpPr>
-        <p:spPr/>
-        <p:txBody>
-          <a:bodyPr/>
+              <a:t>Why a national account would pick us, and what's missing to make that easier.</a:t>
+            </a:r>
+          </a:p>
+        </p:txBody>
+      </p:sp>
+      <p:sp>
+        <p:nvSpPr>
+          <p:cNvPr id="5" name="TextBox 4"/>
+          <p:cNvSpPr txBox="1"/>
+          <p:nvPr/>
+        </p:nvSpPr>
+        <p:spPr>
+          <a:xfrm>
+            <a:off x="731520" y="2121408"/>
+            <a:ext cx="5120640" cy="237744"/>
+          </a:xfrm>
+          <a:prstGeom prst="rect">
+            <a:avLst/>
+          </a:prstGeom>
+          <a:noFill/>
+        </p:spPr>
+        <p:txBody>
+          <a:bodyPr wrap="square" lIns="0" rIns="0" tIns="0" bIns="0">
+            <a:noAutofit/>
+          </a:bodyPr>
           <a:lstStyle/>
           <a:p>
-            <a:r>
-              <a:t>What national accounts count on us for</a:t>
-            </a:r>
-          </a:p>
-        </p:txBody>
-      </p:sp>
-      <p:sp>
-        <p:nvSpPr>
-          <p:cNvPr id="6" name="Text Placeholder 5"/>
-          <p:cNvSpPr>
-            <a:spLocks noGrp="1"/>
-          </p:cNvSpPr>
-          <p:nvPr>
-            <p:ph type="body" idx="105"/>
-          </p:nvPr>
-        </p:nvSpPr>
-        <p:spPr/>
-        <p:txBody>
-          <a:bodyPr/>
+            <a:pPr algn="l"/>
+            <a:r>
+              <a:rPr sz="1100" b="1" i="0">
+                <a:solidFill>
+                  <a:srgbClr val="3C7D4D"/>
+                </a:solidFill>
+                <a:latin typeface="Arial"/>
+              </a:rPr>
+              <a:t>WHY A NATIONAL ACCOUNT PICKS US</a:t>
+            </a:r>
+          </a:p>
+        </p:txBody>
+      </p:sp>
+      <p:graphicFrame>
+        <p:nvGraphicFramePr>
+          <p:cNvPr id="6" name="Table 5"/>
+          <p:cNvGraphicFramePr>
+            <a:graphicFrameLocks noGrp="1"/>
+          </p:cNvGraphicFramePr>
+          <p:nvPr/>
+        </p:nvGraphicFramePr>
+        <p:xfrm>
+          <a:off x="731520" y="2377440"/>
+          <a:ext cx="5120640" cy="3346704"/>
+        </p:xfrm>
+        <a:graphic>
+          <a:graphicData uri="http://schemas.openxmlformats.org/drawingml/2006/table">
+            <a:tbl>
+              <a:tblPr firstRow="0" bandRow="0"/>
+              <a:tblGrid>
+                <a:gridCol w="457200"/>
+                <a:gridCol w="4663440"/>
+              </a:tblGrid>
+              <a:tr h="329184">
+                <a:tc>
+                  <a:txBody>
+                    <a:bodyPr/>
+                    <a:lstStyle/>
+                    <a:p>
+                      <a:r>
+                        <a:rPr sz="1000" b="1">
+                          <a:solidFill>
+                            <a:srgbClr val="FFFFFF"/>
+                          </a:solidFill>
+                          <a:latin typeface="Arial"/>
+                        </a:rPr>
+                        <a:t/>
+                      </a:r>
+                    </a:p>
+                  </a:txBody>
+                  <a:tcPr marL="73152" marR="73152" marT="27432" marB="27432" anchor="ctr">
+                    <a:solidFill>
+                      <a:srgbClr val="3C7D4D"/>
+                    </a:solidFill>
+                    <a:lnL w="6350" cap="flat" cmpd="sng" algn="ctr">
+                      <a:solidFill>
+                        <a:srgbClr val="3C7D4D"/>
+                      </a:solidFill>
+                      <a:prstDash val="solid"/>
+                    </a:lnL>
+                    <a:lnR w="6350" cap="flat" cmpd="sng" algn="ctr">
+                      <a:solidFill>
+                        <a:srgbClr val="3C7D4D"/>
+                      </a:solidFill>
+                      <a:prstDash val="solid"/>
+                    </a:lnR>
+                    <a:lnT w="6350" cap="flat" cmpd="sng" algn="ctr">
+                      <a:solidFill>
+                        <a:srgbClr val="3C7D4D"/>
+                      </a:solidFill>
+                      <a:prstDash val="solid"/>
+                    </a:lnT>
+                    <a:lnB w="6350" cap="flat" cmpd="sng" algn="ctr">
+                      <a:solidFill>
+                        <a:srgbClr val="3C7D4D"/>
+                      </a:solidFill>
+                      <a:prstDash val="solid"/>
+                    </a:lnB>
+                  </a:tcPr>
+                </a:tc>
+                <a:tc>
+                  <a:txBody>
+                    <a:bodyPr/>
+                    <a:lstStyle/>
+                    <a:p>
+                      <a:r>
+                        <a:rPr sz="1000" b="1">
+                          <a:solidFill>
+                            <a:srgbClr val="FFFFFF"/>
+                          </a:solidFill>
+                          <a:latin typeface="Arial"/>
+                        </a:rPr>
+                        <a:t>In their words if you have them</a:t>
+                      </a:r>
+                    </a:p>
+                  </a:txBody>
+                  <a:tcPr marL="73152" marR="73152" marT="27432" marB="27432" anchor="ctr">
+                    <a:solidFill>
+                      <a:srgbClr val="3C7D4D"/>
+                    </a:solidFill>
+                    <a:lnL w="6350" cap="flat" cmpd="sng" algn="ctr">
+                      <a:solidFill>
+                        <a:srgbClr val="3C7D4D"/>
+                      </a:solidFill>
+                      <a:prstDash val="solid"/>
+                    </a:lnL>
+                    <a:lnR w="6350" cap="flat" cmpd="sng" algn="ctr">
+                      <a:solidFill>
+                        <a:srgbClr val="3C7D4D"/>
+                      </a:solidFill>
+                      <a:prstDash val="solid"/>
+                    </a:lnR>
+                    <a:lnT w="6350" cap="flat" cmpd="sng" algn="ctr">
+                      <a:solidFill>
+                        <a:srgbClr val="3C7D4D"/>
+                      </a:solidFill>
+                      <a:prstDash val="solid"/>
+                    </a:lnT>
+                    <a:lnB w="6350" cap="flat" cmpd="sng" algn="ctr">
+                      <a:solidFill>
+                        <a:srgbClr val="3C7D4D"/>
+                      </a:solidFill>
+                      <a:prstDash val="solid"/>
+                    </a:lnB>
+                  </a:tcPr>
+                </a:tc>
+              </a:tr>
+              <a:tr h="1005840">
+                <a:tc>
+                  <a:txBody>
+                    <a:bodyPr/>
+                    <a:lstStyle/>
+                    <a:p>
+                      <a:r>
+                        <a:rPr sz="1000" b="1">
+                          <a:solidFill>
+                            <a:srgbClr val="5B6670"/>
+                          </a:solidFill>
+                          <a:latin typeface="Arial"/>
+                        </a:rPr>
+                        <a:t>1</a:t>
+                      </a:r>
+                    </a:p>
+                  </a:txBody>
+                  <a:tcPr marL="73152" marR="73152" marT="36576" marB="36576" anchor="t">
+                    <a:solidFill>
+                      <a:srgbClr val="F2F5F2"/>
+                    </a:solidFill>
+                    <a:lnL w="6350" cap="flat" cmpd="sng" algn="ctr">
+                      <a:solidFill>
+                        <a:srgbClr val="E2E6E3"/>
+                      </a:solidFill>
+                      <a:prstDash val="solid"/>
+                    </a:lnL>
+                    <a:lnR w="6350" cap="flat" cmpd="sng" algn="ctr">
+                      <a:solidFill>
+                        <a:srgbClr val="E2E6E3"/>
+                      </a:solidFill>
+                      <a:prstDash val="solid"/>
+                    </a:lnR>
+                    <a:lnT w="6350" cap="flat" cmpd="sng" algn="ctr">
+                      <a:solidFill>
+                        <a:srgbClr val="E2E6E3"/>
+                      </a:solidFill>
+                      <a:prstDash val="solid"/>
+                    </a:lnT>
+                    <a:lnB w="6350" cap="flat" cmpd="sng" algn="ctr">
+                      <a:solidFill>
+                        <a:srgbClr val="E2E6E3"/>
+                      </a:solidFill>
+                      <a:prstDash val="solid"/>
+                    </a:lnB>
+                  </a:tcPr>
+                </a:tc>
+                <a:tc>
+                  <a:txBody>
+                    <a:bodyPr/>
+                    <a:lstStyle/>
+                    <a:p>
+                      <a:endParaRPr lang="en-US" sz="1200" b="1">
+                        <a:solidFill>
+                          <a:srgbClr val="15181A"/>
+                        </a:solidFill>
+                        <a:latin typeface="Arial"/>
+                      </a:endParaRPr>
+                    </a:p>
+                  </a:txBody>
+                  <a:tcPr marL="73152" marR="73152" marT="36576" marB="36576" anchor="t">
+                    <a:solidFill>
+                      <a:srgbClr val="FFFFFF"/>
+                    </a:solidFill>
+                    <a:lnL w="6350" cap="flat" cmpd="sng" algn="ctr">
+                      <a:solidFill>
+                        <a:srgbClr val="E2E6E3"/>
+                      </a:solidFill>
+                      <a:prstDash val="solid"/>
+                    </a:lnL>
+                    <a:lnR w="6350" cap="flat" cmpd="sng" algn="ctr">
+                      <a:solidFill>
+                        <a:srgbClr val="E2E6E3"/>
+                      </a:solidFill>
+                      <a:prstDash val="solid"/>
+                    </a:lnR>
+                    <a:lnT w="6350" cap="flat" cmpd="sng" algn="ctr">
+                      <a:solidFill>
+                        <a:srgbClr val="E2E6E3"/>
+                      </a:solidFill>
+                      <a:prstDash val="solid"/>
+                    </a:lnT>
+                    <a:lnB w="6350" cap="flat" cmpd="sng" algn="ctr">
+                      <a:solidFill>
+                        <a:srgbClr val="E2E6E3"/>
+                      </a:solidFill>
+                      <a:prstDash val="solid"/>
+                    </a:lnB>
+                  </a:tcPr>
+                </a:tc>
+              </a:tr>
+              <a:tr h="1005840">
+                <a:tc>
+                  <a:txBody>
+                    <a:bodyPr/>
+                    <a:lstStyle/>
+                    <a:p>
+                      <a:r>
+                        <a:rPr sz="1000" b="1">
+                          <a:solidFill>
+                            <a:srgbClr val="5B6670"/>
+                          </a:solidFill>
+                          <a:latin typeface="Arial"/>
+                        </a:rPr>
+                        <a:t>2</a:t>
+                      </a:r>
+                    </a:p>
+                  </a:txBody>
+                  <a:tcPr marL="73152" marR="73152" marT="36576" marB="36576" anchor="t">
+                    <a:solidFill>
+                      <a:srgbClr val="F2F5F2"/>
+                    </a:solidFill>
+                    <a:lnL w="6350" cap="flat" cmpd="sng" algn="ctr">
+                      <a:solidFill>
+                        <a:srgbClr val="E2E6E3"/>
+                      </a:solidFill>
+                      <a:prstDash val="solid"/>
+                    </a:lnL>
+                    <a:lnR w="6350" cap="flat" cmpd="sng" algn="ctr">
+                      <a:solidFill>
+                        <a:srgbClr val="E2E6E3"/>
+                      </a:solidFill>
+                      <a:prstDash val="solid"/>
+                    </a:lnR>
+                    <a:lnT w="6350" cap="flat" cmpd="sng" algn="ctr">
+                      <a:solidFill>
+                        <a:srgbClr val="E2E6E3"/>
+                      </a:solidFill>
+                      <a:prstDash val="solid"/>
+                    </a:lnT>
+                    <a:lnB w="6350" cap="flat" cmpd="sng" algn="ctr">
+                      <a:solidFill>
+                        <a:srgbClr val="E2E6E3"/>
+                      </a:solidFill>
+                      <a:prstDash val="solid"/>
+                    </a:lnB>
+                  </a:tcPr>
+                </a:tc>
+                <a:tc>
+                  <a:txBody>
+                    <a:bodyPr/>
+                    <a:lstStyle/>
+                    <a:p>
+                      <a:endParaRPr lang="en-US" sz="1200" b="1">
+                        <a:solidFill>
+                          <a:srgbClr val="15181A"/>
+                        </a:solidFill>
+                        <a:latin typeface="Arial"/>
+                      </a:endParaRPr>
+                    </a:p>
+                  </a:txBody>
+                  <a:tcPr marL="73152" marR="73152" marT="36576" marB="36576" anchor="t">
+                    <a:solidFill>
+                      <a:srgbClr val="FFFFFF"/>
+                    </a:solidFill>
+                    <a:lnL w="6350" cap="flat" cmpd="sng" algn="ctr">
+                      <a:solidFill>
+                        <a:srgbClr val="E2E6E3"/>
+                      </a:solidFill>
+                      <a:prstDash val="solid"/>
+                    </a:lnL>
+                    <a:lnR w="6350" cap="flat" cmpd="sng" algn="ctr">
+                      <a:solidFill>
+                        <a:srgbClr val="E2E6E3"/>
+                      </a:solidFill>
+                      <a:prstDash val="solid"/>
+                    </a:lnR>
+                    <a:lnT w="6350" cap="flat" cmpd="sng" algn="ctr">
+                      <a:solidFill>
+                        <a:srgbClr val="E2E6E3"/>
+                      </a:solidFill>
+                      <a:prstDash val="solid"/>
+                    </a:lnT>
+                    <a:lnB w="6350" cap="flat" cmpd="sng" algn="ctr">
+                      <a:solidFill>
+                        <a:srgbClr val="E2E6E3"/>
+                      </a:solidFill>
+                      <a:prstDash val="solid"/>
+                    </a:lnB>
+                  </a:tcPr>
+                </a:tc>
+              </a:tr>
+              <a:tr h="1005840">
+                <a:tc>
+                  <a:txBody>
+                    <a:bodyPr/>
+                    <a:lstStyle/>
+                    <a:p>
+                      <a:r>
+                        <a:rPr sz="1000" b="1">
+                          <a:solidFill>
+                            <a:srgbClr val="5B6670"/>
+                          </a:solidFill>
+                          <a:latin typeface="Arial"/>
+                        </a:rPr>
+                        <a:t>3</a:t>
+                      </a:r>
+                    </a:p>
+                  </a:txBody>
+                  <a:tcPr marL="73152" marR="73152" marT="36576" marB="36576" anchor="t">
+                    <a:solidFill>
+                      <a:srgbClr val="F2F5F2"/>
+                    </a:solidFill>
+                    <a:lnL w="6350" cap="flat" cmpd="sng" algn="ctr">
+                      <a:solidFill>
+                        <a:srgbClr val="E2E6E3"/>
+                      </a:solidFill>
+                      <a:prstDash val="solid"/>
+                    </a:lnL>
+                    <a:lnR w="6350" cap="flat" cmpd="sng" algn="ctr">
+                      <a:solidFill>
+                        <a:srgbClr val="E2E6E3"/>
+                      </a:solidFill>
+                      <a:prstDash val="solid"/>
+                    </a:lnR>
+                    <a:lnT w="6350" cap="flat" cmpd="sng" algn="ctr">
+                      <a:solidFill>
+                        <a:srgbClr val="E2E6E3"/>
+                      </a:solidFill>
+                      <a:prstDash val="solid"/>
+                    </a:lnT>
+                    <a:lnB w="6350" cap="flat" cmpd="sng" algn="ctr">
+                      <a:solidFill>
+                        <a:srgbClr val="E2E6E3"/>
+                      </a:solidFill>
+                      <a:prstDash val="solid"/>
+                    </a:lnB>
+                  </a:tcPr>
+                </a:tc>
+                <a:tc>
+                  <a:txBody>
+                    <a:bodyPr/>
+                    <a:lstStyle/>
+                    <a:p>
+                      <a:endParaRPr lang="en-US" sz="1200" b="1">
+                        <a:solidFill>
+                          <a:srgbClr val="15181A"/>
+                        </a:solidFill>
+                        <a:latin typeface="Arial"/>
+                      </a:endParaRPr>
+                    </a:p>
+                  </a:txBody>
+                  <a:tcPr marL="73152" marR="73152" marT="36576" marB="36576" anchor="t">
+                    <a:solidFill>
+                      <a:srgbClr val="FFFFFF"/>
+                    </a:solidFill>
+                    <a:lnL w="6350" cap="flat" cmpd="sng" algn="ctr">
+                      <a:solidFill>
+                        <a:srgbClr val="E2E6E3"/>
+                      </a:solidFill>
+                      <a:prstDash val="solid"/>
+                    </a:lnL>
+                    <a:lnR w="6350" cap="flat" cmpd="sng" algn="ctr">
+                      <a:solidFill>
+                        <a:srgbClr val="E2E6E3"/>
+                      </a:solidFill>
+                      <a:prstDash val="solid"/>
+                    </a:lnR>
+                    <a:lnT w="6350" cap="flat" cmpd="sng" algn="ctr">
+                      <a:solidFill>
+                        <a:srgbClr val="E2E6E3"/>
+                      </a:solidFill>
+                      <a:prstDash val="solid"/>
+                    </a:lnT>
+                    <a:lnB w="6350" cap="flat" cmpd="sng" algn="ctr">
+                      <a:solidFill>
+                        <a:srgbClr val="E2E6E3"/>
+                      </a:solidFill>
+                      <a:prstDash val="solid"/>
+                    </a:lnB>
+                  </a:tcPr>
+                </a:tc>
+              </a:tr>
+            </a:tbl>
+          </a:graphicData>
+        </a:graphic>
+      </p:graphicFrame>
+      <p:sp>
+        <p:nvSpPr>
+          <p:cNvPr id="7" name="TextBox 6"/>
+          <p:cNvSpPr txBox="1"/>
+          <p:nvPr/>
+        </p:nvSpPr>
+        <p:spPr>
+          <a:xfrm>
+            <a:off x="6519672" y="2121408"/>
+            <a:ext cx="4937760" cy="237744"/>
+          </a:xfrm>
+          <a:prstGeom prst="rect">
+            <a:avLst/>
+          </a:prstGeom>
+          <a:noFill/>
+        </p:spPr>
+        <p:txBody>
+          <a:bodyPr wrap="square" lIns="0" rIns="0" tIns="0" bIns="0">
+            <a:noAutofit/>
+          </a:bodyPr>
           <a:lstStyle/>
           <a:p>
-            <a:r>
-              <a:t>1. [ ]</a:t>
-            </a:r>
-          </a:p>
-          <a:p>
-            <a:r>
-              <a:t>2. [ ]</a:t>
-            </a:r>
-          </a:p>
-          <a:p>
-            <a:r>
-              <a:t>3. [ ]</a:t>
-            </a:r>
-          </a:p>
-        </p:txBody>
-      </p:sp>
-      <p:sp>
-        <p:nvSpPr>
-          <p:cNvPr id="7" name="Text Placeholder 6"/>
-          <p:cNvSpPr>
-            <a:spLocks noGrp="1"/>
-          </p:cNvSpPr>
-          <p:nvPr>
-            <p:ph type="body" idx="106"/>
-          </p:nvPr>
-        </p:nvSpPr>
-        <p:spPr/>
-        <p:txBody>
-          <a:bodyPr/>
+            <a:pPr algn="l"/>
+            <a:r>
+              <a:rPr sz="1100" b="1" i="0">
+                <a:solidFill>
+                  <a:srgbClr val="3C7D4D"/>
+                </a:solidFill>
+                <a:latin typeface="Arial"/>
+              </a:rPr>
+              <a:t>WHAT'S MISSING TO MAKE THAT EASIER</a:t>
+            </a:r>
+          </a:p>
+        </p:txBody>
+      </p:sp>
+      <p:graphicFrame>
+        <p:nvGraphicFramePr>
+          <p:cNvPr id="8" name="Table 7"/>
+          <p:cNvGraphicFramePr>
+            <a:graphicFrameLocks noGrp="1"/>
+          </p:cNvGraphicFramePr>
+          <p:nvPr/>
+        </p:nvGraphicFramePr>
+        <p:xfrm>
+          <a:off x="6519672" y="2377440"/>
+          <a:ext cx="4937760" cy="3346704"/>
+        </p:xfrm>
+        <a:graphic>
+          <a:graphicData uri="http://schemas.openxmlformats.org/drawingml/2006/table">
+            <a:tbl>
+              <a:tblPr firstRow="0" bandRow="0"/>
+              <a:tblGrid>
+                <a:gridCol w="1554480"/>
+                <a:gridCol w="3383280"/>
+              </a:tblGrid>
+              <a:tr h="329184">
+                <a:tc>
+                  <a:txBody>
+                    <a:bodyPr/>
+                    <a:lstStyle/>
+                    <a:p>
+                      <a:r>
+                        <a:rPr sz="1000" b="1">
+                          <a:solidFill>
+                            <a:srgbClr val="FFFFFF"/>
+                          </a:solidFill>
+                          <a:latin typeface="Arial"/>
+                        </a:rPr>
+                        <a:t/>
+                      </a:r>
+                    </a:p>
+                  </a:txBody>
+                  <a:tcPr marL="73152" marR="73152" marT="27432" marB="27432" anchor="ctr">
+                    <a:solidFill>
+                      <a:srgbClr val="3C7D4D"/>
+                    </a:solidFill>
+                    <a:lnL w="6350" cap="flat" cmpd="sng" algn="ctr">
+                      <a:solidFill>
+                        <a:srgbClr val="3C7D4D"/>
+                      </a:solidFill>
+                      <a:prstDash val="solid"/>
+                    </a:lnL>
+                    <a:lnR w="6350" cap="flat" cmpd="sng" algn="ctr">
+                      <a:solidFill>
+                        <a:srgbClr val="3C7D4D"/>
+                      </a:solidFill>
+                      <a:prstDash val="solid"/>
+                    </a:lnR>
+                    <a:lnT w="6350" cap="flat" cmpd="sng" algn="ctr">
+                      <a:solidFill>
+                        <a:srgbClr val="3C7D4D"/>
+                      </a:solidFill>
+                      <a:prstDash val="solid"/>
+                    </a:lnT>
+                    <a:lnB w="6350" cap="flat" cmpd="sng" algn="ctr">
+                      <a:solidFill>
+                        <a:srgbClr val="3C7D4D"/>
+                      </a:solidFill>
+                      <a:prstDash val="solid"/>
+                    </a:lnB>
+                  </a:tcPr>
+                </a:tc>
+                <a:tc>
+                  <a:txBody>
+                    <a:bodyPr/>
+                    <a:lstStyle/>
+                    <a:p>
+                      <a:r>
+                        <a:rPr sz="1000" b="1">
+                          <a:solidFill>
+                            <a:srgbClr val="FFFFFF"/>
+                          </a:solidFill>
+                          <a:latin typeface="Arial"/>
+                        </a:rPr>
+                        <a:t>One gap. The one that costs the most.</a:t>
+                      </a:r>
+                    </a:p>
+                  </a:txBody>
+                  <a:tcPr marL="73152" marR="73152" marT="27432" marB="27432" anchor="ctr">
+                    <a:solidFill>
+                      <a:srgbClr val="3C7D4D"/>
+                    </a:solidFill>
+                    <a:lnL w="6350" cap="flat" cmpd="sng" algn="ctr">
+                      <a:solidFill>
+                        <a:srgbClr val="3C7D4D"/>
+                      </a:solidFill>
+                      <a:prstDash val="solid"/>
+                    </a:lnL>
+                    <a:lnR w="6350" cap="flat" cmpd="sng" algn="ctr">
+                      <a:solidFill>
+                        <a:srgbClr val="3C7D4D"/>
+                      </a:solidFill>
+                      <a:prstDash val="solid"/>
+                    </a:lnR>
+                    <a:lnT w="6350" cap="flat" cmpd="sng" algn="ctr">
+                      <a:solidFill>
+                        <a:srgbClr val="3C7D4D"/>
+                      </a:solidFill>
+                      <a:prstDash val="solid"/>
+                    </a:lnT>
+                    <a:lnB w="6350" cap="flat" cmpd="sng" algn="ctr">
+                      <a:solidFill>
+                        <a:srgbClr val="3C7D4D"/>
+                      </a:solidFill>
+                      <a:prstDash val="solid"/>
+                    </a:lnB>
+                  </a:tcPr>
+                </a:tc>
+              </a:tr>
+              <a:tr h="1005840">
+                <a:tc>
+                  <a:txBody>
+                    <a:bodyPr/>
+                    <a:lstStyle/>
+                    <a:p>
+                      <a:r>
+                        <a:rPr sz="1000" b="1">
+                          <a:solidFill>
+                            <a:srgbClr val="5B6670"/>
+                          </a:solidFill>
+                          <a:latin typeface="Arial"/>
+                        </a:rPr>
+                        <a:t>The gap</a:t>
+                      </a:r>
+                    </a:p>
+                  </a:txBody>
+                  <a:tcPr marL="73152" marR="73152" marT="36576" marB="36576" anchor="t">
+                    <a:solidFill>
+                      <a:srgbClr val="F2F5F2"/>
+                    </a:solidFill>
+                    <a:lnL w="6350" cap="flat" cmpd="sng" algn="ctr">
+                      <a:solidFill>
+                        <a:srgbClr val="E2E6E3"/>
+                      </a:solidFill>
+                      <a:prstDash val="solid"/>
+                    </a:lnL>
+                    <a:lnR w="6350" cap="flat" cmpd="sng" algn="ctr">
+                      <a:solidFill>
+                        <a:srgbClr val="E2E6E3"/>
+                      </a:solidFill>
+                      <a:prstDash val="solid"/>
+                    </a:lnR>
+                    <a:lnT w="6350" cap="flat" cmpd="sng" algn="ctr">
+                      <a:solidFill>
+                        <a:srgbClr val="E2E6E3"/>
+                      </a:solidFill>
+                      <a:prstDash val="solid"/>
+                    </a:lnT>
+                    <a:lnB w="6350" cap="flat" cmpd="sng" algn="ctr">
+                      <a:solidFill>
+                        <a:srgbClr val="E2E6E3"/>
+                      </a:solidFill>
+                      <a:prstDash val="solid"/>
+                    </a:lnB>
+                  </a:tcPr>
+                </a:tc>
+                <a:tc>
+                  <a:txBody>
+                    <a:bodyPr/>
+                    <a:lstStyle/>
+                    <a:p>
+                      <a:endParaRPr lang="en-US" sz="1200" b="1">
+                        <a:solidFill>
+                          <a:srgbClr val="15181A"/>
+                        </a:solidFill>
+                        <a:latin typeface="Arial"/>
+                      </a:endParaRPr>
+                    </a:p>
+                  </a:txBody>
+                  <a:tcPr marL="73152" marR="73152" marT="36576" marB="36576" anchor="t">
+                    <a:solidFill>
+                      <a:srgbClr val="FFFFFF"/>
+                    </a:solidFill>
+                    <a:lnL w="6350" cap="flat" cmpd="sng" algn="ctr">
+                      <a:solidFill>
+                        <a:srgbClr val="E2E6E3"/>
+                      </a:solidFill>
+                      <a:prstDash val="solid"/>
+                    </a:lnL>
+                    <a:lnR w="6350" cap="flat" cmpd="sng" algn="ctr">
+                      <a:solidFill>
+                        <a:srgbClr val="E2E6E3"/>
+                      </a:solidFill>
+                      <a:prstDash val="solid"/>
+                    </a:lnR>
+                    <a:lnT w="6350" cap="flat" cmpd="sng" algn="ctr">
+                      <a:solidFill>
+                        <a:srgbClr val="E2E6E3"/>
+                      </a:solidFill>
+                      <a:prstDash val="solid"/>
+                    </a:lnT>
+                    <a:lnB w="6350" cap="flat" cmpd="sng" algn="ctr">
+                      <a:solidFill>
+                        <a:srgbClr val="E2E6E3"/>
+                      </a:solidFill>
+                      <a:prstDash val="solid"/>
+                    </a:lnB>
+                  </a:tcPr>
+                </a:tc>
+              </a:tr>
+              <a:tr h="1005840">
+                <a:tc>
+                  <a:txBody>
+                    <a:bodyPr/>
+                    <a:lstStyle/>
+                    <a:p>
+                      <a:r>
+                        <a:rPr sz="1000" b="1">
+                          <a:solidFill>
+                            <a:srgbClr val="5B6670"/>
+                          </a:solidFill>
+                          <a:latin typeface="Arial"/>
+                        </a:rPr>
+                        <a:t>What it costs us</a:t>
+                      </a:r>
+                    </a:p>
+                  </a:txBody>
+                  <a:tcPr marL="73152" marR="73152" marT="36576" marB="36576" anchor="t">
+                    <a:solidFill>
+                      <a:srgbClr val="F2F5F2"/>
+                    </a:solidFill>
+                    <a:lnL w="6350" cap="flat" cmpd="sng" algn="ctr">
+                      <a:solidFill>
+                        <a:srgbClr val="E2E6E3"/>
+                      </a:solidFill>
+                      <a:prstDash val="solid"/>
+                    </a:lnL>
+                    <a:lnR w="6350" cap="flat" cmpd="sng" algn="ctr">
+                      <a:solidFill>
+                        <a:srgbClr val="E2E6E3"/>
+                      </a:solidFill>
+                      <a:prstDash val="solid"/>
+                    </a:lnR>
+                    <a:lnT w="6350" cap="flat" cmpd="sng" algn="ctr">
+                      <a:solidFill>
+                        <a:srgbClr val="E2E6E3"/>
+                      </a:solidFill>
+                      <a:prstDash val="solid"/>
+                    </a:lnT>
+                    <a:lnB w="6350" cap="flat" cmpd="sng" algn="ctr">
+                      <a:solidFill>
+                        <a:srgbClr val="E2E6E3"/>
+                      </a:solidFill>
+                      <a:prstDash val="solid"/>
+                    </a:lnB>
+                  </a:tcPr>
+                </a:tc>
+                <a:tc>
+                  <a:txBody>
+                    <a:bodyPr/>
+                    <a:lstStyle/>
+                    <a:p>
+                      <a:endParaRPr lang="en-US" sz="1200" b="1">
+                        <a:solidFill>
+                          <a:srgbClr val="15181A"/>
+                        </a:solidFill>
+                        <a:latin typeface="Arial"/>
+                      </a:endParaRPr>
+                    </a:p>
+                  </a:txBody>
+                  <a:tcPr marL="73152" marR="73152" marT="36576" marB="36576" anchor="t">
+                    <a:solidFill>
+                      <a:srgbClr val="FFFFFF"/>
+                    </a:solidFill>
+                    <a:lnL w="6350" cap="flat" cmpd="sng" algn="ctr">
+                      <a:solidFill>
+                        <a:srgbClr val="E2E6E3"/>
+                      </a:solidFill>
+                      <a:prstDash val="solid"/>
+                    </a:lnL>
+                    <a:lnR w="6350" cap="flat" cmpd="sng" algn="ctr">
+                      <a:solidFill>
+                        <a:srgbClr val="E2E6E3"/>
+                      </a:solidFill>
+                      <a:prstDash val="solid"/>
+                    </a:lnR>
+                    <a:lnT w="6350" cap="flat" cmpd="sng" algn="ctr">
+                      <a:solidFill>
+                        <a:srgbClr val="E2E6E3"/>
+                      </a:solidFill>
+                      <a:prstDash val="solid"/>
+                    </a:lnT>
+                    <a:lnB w="6350" cap="flat" cmpd="sng" algn="ctr">
+                      <a:solidFill>
+                        <a:srgbClr val="E2E6E3"/>
+                      </a:solidFill>
+                      <a:prstDash val="solid"/>
+                    </a:lnB>
+                  </a:tcPr>
+                </a:tc>
+              </a:tr>
+              <a:tr h="1005840">
+                <a:tc>
+                  <a:txBody>
+                    <a:bodyPr/>
+                    <a:lstStyle/>
+                    <a:p>
+                      <a:r>
+                        <a:rPr sz="1000" b="1">
+                          <a:solidFill>
+                            <a:srgbClr val="5B6670"/>
+                          </a:solidFill>
+                          <a:latin typeface="Arial"/>
+                        </a:rPr>
+                        <a:t>What would fix it</a:t>
+                      </a:r>
+                    </a:p>
+                  </a:txBody>
+                  <a:tcPr marL="73152" marR="73152" marT="36576" marB="36576" anchor="t">
+                    <a:solidFill>
+                      <a:srgbClr val="F2F5F2"/>
+                    </a:solidFill>
+                    <a:lnL w="6350" cap="flat" cmpd="sng" algn="ctr">
+                      <a:solidFill>
+                        <a:srgbClr val="E2E6E3"/>
+                      </a:solidFill>
+                      <a:prstDash val="solid"/>
+                    </a:lnL>
+                    <a:lnR w="6350" cap="flat" cmpd="sng" algn="ctr">
+                      <a:solidFill>
+                        <a:srgbClr val="E2E6E3"/>
+                      </a:solidFill>
+                      <a:prstDash val="solid"/>
+                    </a:lnR>
+                    <a:lnT w="6350" cap="flat" cmpd="sng" algn="ctr">
+                      <a:solidFill>
+                        <a:srgbClr val="E2E6E3"/>
+                      </a:solidFill>
+                      <a:prstDash val="solid"/>
+                    </a:lnT>
+                    <a:lnB w="6350" cap="flat" cmpd="sng" algn="ctr">
+                      <a:solidFill>
+                        <a:srgbClr val="E2E6E3"/>
+                      </a:solidFill>
+                      <a:prstDash val="solid"/>
+                    </a:lnB>
+                  </a:tcPr>
+                </a:tc>
+                <a:tc>
+                  <a:txBody>
+                    <a:bodyPr/>
+                    <a:lstStyle/>
+                    <a:p>
+                      <a:endParaRPr lang="en-US" sz="1200" b="1">
+                        <a:solidFill>
+                          <a:srgbClr val="15181A"/>
+                        </a:solidFill>
+                        <a:latin typeface="Arial"/>
+                      </a:endParaRPr>
+                    </a:p>
+                  </a:txBody>
+                  <a:tcPr marL="73152" marR="73152" marT="36576" marB="36576" anchor="t">
+                    <a:solidFill>
+                      <a:srgbClr val="FFFFFF"/>
+                    </a:solidFill>
+                    <a:lnL w="6350" cap="flat" cmpd="sng" algn="ctr">
+                      <a:solidFill>
+                        <a:srgbClr val="E2E6E3"/>
+                      </a:solidFill>
+                      <a:prstDash val="solid"/>
+                    </a:lnL>
+                    <a:lnR w="6350" cap="flat" cmpd="sng" algn="ctr">
+                      <a:solidFill>
+                        <a:srgbClr val="E2E6E3"/>
+                      </a:solidFill>
+                      <a:prstDash val="solid"/>
+                    </a:lnR>
+                    <a:lnT w="6350" cap="flat" cmpd="sng" algn="ctr">
+                      <a:solidFill>
+                        <a:srgbClr val="E2E6E3"/>
+                      </a:solidFill>
+                      <a:prstDash val="solid"/>
+                    </a:lnT>
+                    <a:lnB w="6350" cap="flat" cmpd="sng" algn="ctr">
+                      <a:solidFill>
+                        <a:srgbClr val="E2E6E3"/>
+                      </a:solidFill>
+                      <a:prstDash val="solid"/>
+                    </a:lnB>
+                  </a:tcPr>
+                </a:tc>
+              </a:tr>
+            </a:tbl>
+          </a:graphicData>
+        </a:graphic>
+      </p:graphicFrame>
+      <p:sp>
+        <p:nvSpPr>
+          <p:cNvPr id="9" name="TextBox 8"/>
+          <p:cNvSpPr txBox="1"/>
+          <p:nvPr/>
+        </p:nvSpPr>
+        <p:spPr>
+          <a:xfrm>
+            <a:off x="731520" y="5797296"/>
+            <a:ext cx="10725912" cy="237744"/>
+          </a:xfrm>
+          <a:prstGeom prst="rect">
+            <a:avLst/>
+          </a:prstGeom>
+          <a:noFill/>
+        </p:spPr>
+        <p:txBody>
+          <a:bodyPr wrap="square" lIns="0" rIns="0" tIns="0" bIns="0">
+            <a:noAutofit/>
+          </a:bodyPr>
           <a:lstStyle/>
           <a:p>
-            <a:r>
-              <a:t>The one gap that costs me the most</a:t>
-            </a:r>
-          </a:p>
-        </p:txBody>
-      </p:sp>
-      <p:sp>
-        <p:nvSpPr>
-          <p:cNvPr id="8" name="Text Placeholder 7"/>
-          <p:cNvSpPr>
-            <a:spLocks noGrp="1"/>
-          </p:cNvSpPr>
-          <p:nvPr>
-            <p:ph type="body" idx="108"/>
-          </p:nvPr>
-        </p:nvSpPr>
-        <p:spPr/>
-        <p:txBody>
-          <a:bodyPr/>
-          <a:lstStyle/>
-          <a:p>
-            <a:r>
-              <a:t>The gap: [product or resource]</a:t>
-            </a:r>
-          </a:p>
-          <a:p>
-            <a:r>
-              <a:t>What it costs: [jobs, dealers, or $]</a:t>
-            </a:r>
-          </a:p>
-          <a:p>
-            <a:r>
-              <a:t>What would fix it: [ ]</a:t>
+            <a:pPr algn="l"/>
+            <a:r>
+              <a:rPr sz="1100" b="1" i="0">
+                <a:solidFill>
+                  <a:srgbClr val="3C7D4D"/>
+                </a:solidFill>
+                <a:latin typeface="Arial"/>
+              </a:rPr>
+              <a:t>For the room:  Is this the same reason the dealers give?</a:t>
             </a:r>
           </a:p>
         </p:txBody>
@@ -13321,7 +14054,7 @@
           <a:lstStyle/>
           <a:p>
             <a:r>
-              <a:t>How I'm getting in the door</a:t>
+              <a:t>Getting in the door</a:t>
             </a:r>
           </a:p>
         </p:txBody>
@@ -13342,7 +14075,7 @@
           <a:lstStyle/>
           <a:p>
             <a:r>
-              <a:t>[One line. The way in that's actually producing meetings.]</a:t>
+              <a:t>How you're getting in the door with national accounts, and what's working.</a:t>
             </a:r>
           </a:p>
         </p:txBody>
@@ -13370,27 +14103,6 @@
       </p:sp>
       <p:sp>
         <p:nvSpPr>
-          <p:cNvPr id="6" name="Text Placeholder 5"/>
-          <p:cNvSpPr>
-            <a:spLocks noGrp="1"/>
-          </p:cNvSpPr>
-          <p:nvPr>
-            <p:ph type="body" idx="107"/>
-          </p:nvPr>
-        </p:nvSpPr>
-        <p:spPr/>
-        <p:txBody>
-          <a:bodyPr/>
-          <a:lstStyle/>
-          <a:p>
-            <a:r>
-              <a:t>[Referrals, shows, integrators, outreach, whatever it really is]</a:t>
-            </a:r>
-          </a:p>
-        </p:txBody>
-      </p:sp>
-      <p:sp>
-        <p:nvSpPr>
           <p:cNvPr id="7" name="Text Placeholder 6"/>
           <p:cNvSpPr>
             <a:spLocks noGrp="1"/>
@@ -13412,27 +14124,6 @@
       </p:sp>
       <p:sp>
         <p:nvSpPr>
-          <p:cNvPr id="8" name="Text Placeholder 7"/>
-          <p:cNvSpPr>
-            <a:spLocks noGrp="1"/>
-          </p:cNvSpPr>
-          <p:nvPr>
-            <p:ph type="body" idx="112"/>
-          </p:nvPr>
-        </p:nvSpPr>
-        <p:spPr/>
-        <p:txBody>
-          <a:bodyPr/>
-          <a:lstStyle/>
-          <a:p>
-            <a:r>
-              <a:t>[ ]</a:t>
-            </a:r>
-          </a:p>
-        </p:txBody>
-      </p:sp>
-      <p:sp>
-        <p:nvSpPr>
           <p:cNvPr id="9" name="Text Placeholder 8"/>
           <p:cNvSpPr>
             <a:spLocks noGrp="1"/>
@@ -13454,22 +14145,220 @@
       </p:sp>
       <p:sp>
         <p:nvSpPr>
-          <p:cNvPr id="10" name="Text Placeholder 9"/>
-          <p:cNvSpPr>
-            <a:spLocks noGrp="1"/>
-          </p:cNvSpPr>
-          <p:nvPr>
-            <p:ph type="body" idx="117"/>
-          </p:nvPr>
-        </p:nvSpPr>
-        <p:spPr/>
-        <p:txBody>
-          <a:bodyPr/>
+          <p:cNvPr id="12" name="TextBox 11"/>
+          <p:cNvSpPr txBox="1"/>
+          <p:nvPr/>
+        </p:nvSpPr>
+        <p:spPr>
+          <a:xfrm>
+            <a:off x="1097280" y="3931920"/>
+            <a:ext cx="2660904" cy="237744"/>
+          </a:xfrm>
+          <a:prstGeom prst="rect">
+            <a:avLst/>
+          </a:prstGeom>
+          <a:noFill/>
+        </p:spPr>
+        <p:txBody>
+          <a:bodyPr wrap="square" lIns="0" rIns="0" tIns="0" bIns="0">
+            <a:noAutofit/>
+          </a:bodyPr>
           <a:lstStyle/>
           <a:p>
-            <a:r>
-              <a:t>[ ]</a:t>
-            </a:r>
+            <a:pPr algn="l"/>
+            <a:r>
+              <a:rPr sz="1000" b="0" i="0">
+                <a:solidFill>
+                  <a:srgbClr val="5B6670"/>
+                </a:solidFill>
+                <a:latin typeface="Arial"/>
+              </a:rPr>
+              <a:t>Referrals, shows, integrators, outreach</a:t>
+            </a:r>
+          </a:p>
+        </p:txBody>
+      </p:sp>
+      <p:sp>
+        <p:nvSpPr>
+          <p:cNvPr id="13" name="TextBox 12"/>
+          <p:cNvSpPr txBox="1"/>
+          <p:nvPr/>
+        </p:nvSpPr>
+        <p:spPr>
+          <a:xfrm>
+            <a:off x="1097280" y="4206240"/>
+            <a:ext cx="2660904" cy="1316736"/>
+          </a:xfrm>
+          <a:prstGeom prst="rect">
+            <a:avLst/>
+          </a:prstGeom>
+          <a:solidFill>
+            <a:srgbClr val="FFFFFF"/>
+          </a:solidFill>
+          <a:ln w="9525">
+            <a:solidFill>
+              <a:srgbClr val="E2E6E3"/>
+            </a:solidFill>
+          </a:ln>
+        </p:spPr>
+        <p:txBody>
+          <a:bodyPr wrap="square" tIns="73152" bIns="73152">
+            <a:noAutofit/>
+          </a:bodyPr>
+          <a:lstStyle/>
+          <a:p>
+            <a:endParaRPr lang="en-US" sz="1200" b="1">
+              <a:solidFill>
+                <a:srgbClr val="15181A"/>
+              </a:solidFill>
+              <a:latin typeface="Arial"/>
+            </a:endParaRPr>
+          </a:p>
+        </p:txBody>
+      </p:sp>
+      <p:sp>
+        <p:nvSpPr>
+          <p:cNvPr id="14" name="TextBox 13"/>
+          <p:cNvSpPr txBox="1"/>
+          <p:nvPr/>
+        </p:nvSpPr>
+        <p:spPr>
+          <a:xfrm>
+            <a:off x="4773168" y="3931920"/>
+            <a:ext cx="2660904" cy="237744"/>
+          </a:xfrm>
+          <a:prstGeom prst="rect">
+            <a:avLst/>
+          </a:prstGeom>
+          <a:noFill/>
+        </p:spPr>
+        <p:txBody>
+          <a:bodyPr wrap="square" lIns="0" rIns="0" tIns="0" bIns="0">
+            <a:noAutofit/>
+          </a:bodyPr>
+          <a:lstStyle/>
+          <a:p>
+            <a:pPr algn="l"/>
+            <a:r>
+              <a:rPr sz="1000" b="0" i="0">
+                <a:solidFill>
+                  <a:srgbClr val="5B6670"/>
+                </a:solidFill>
+                <a:latin typeface="Arial"/>
+              </a:rPr>
+              <a:t>And why</a:t>
+            </a:r>
+          </a:p>
+        </p:txBody>
+      </p:sp>
+      <p:sp>
+        <p:nvSpPr>
+          <p:cNvPr id="15" name="TextBox 14"/>
+          <p:cNvSpPr txBox="1"/>
+          <p:nvPr/>
+        </p:nvSpPr>
+        <p:spPr>
+          <a:xfrm>
+            <a:off x="4773168" y="4206240"/>
+            <a:ext cx="2660904" cy="1316736"/>
+          </a:xfrm>
+          <a:prstGeom prst="rect">
+            <a:avLst/>
+          </a:prstGeom>
+          <a:solidFill>
+            <a:srgbClr val="FFFFFF"/>
+          </a:solidFill>
+          <a:ln w="9525">
+            <a:solidFill>
+              <a:srgbClr val="E2E6E3"/>
+            </a:solidFill>
+          </a:ln>
+        </p:spPr>
+        <p:txBody>
+          <a:bodyPr wrap="square" tIns="73152" bIns="73152">
+            <a:noAutofit/>
+          </a:bodyPr>
+          <a:lstStyle/>
+          <a:p>
+            <a:endParaRPr lang="en-US" sz="1200" b="1">
+              <a:solidFill>
+                <a:srgbClr val="15181A"/>
+              </a:solidFill>
+              <a:latin typeface="Arial"/>
+            </a:endParaRPr>
+          </a:p>
+        </p:txBody>
+      </p:sp>
+      <p:sp>
+        <p:nvSpPr>
+          <p:cNvPr id="16" name="TextBox 15"/>
+          <p:cNvSpPr txBox="1"/>
+          <p:nvPr/>
+        </p:nvSpPr>
+        <p:spPr>
+          <a:xfrm>
+            <a:off x="8449056" y="3931920"/>
+            <a:ext cx="2660904" cy="237744"/>
+          </a:xfrm>
+          <a:prstGeom prst="rect">
+            <a:avLst/>
+          </a:prstGeom>
+          <a:noFill/>
+        </p:spPr>
+        <p:txBody>
+          <a:bodyPr wrap="square" lIns="0" rIns="0" tIns="0" bIns="0">
+            <a:noAutofit/>
+          </a:bodyPr>
+          <a:lstStyle/>
+          <a:p>
+            <a:pPr algn="l"/>
+            <a:r>
+              <a:rPr sz="1000" b="0" i="0">
+                <a:solidFill>
+                  <a:srgbClr val="5B6670"/>
+                </a:solidFill>
+                <a:latin typeface="Arial"/>
+              </a:rPr>
+              <a:t>And what would help</a:t>
+            </a:r>
+          </a:p>
+        </p:txBody>
+      </p:sp>
+      <p:sp>
+        <p:nvSpPr>
+          <p:cNvPr id="17" name="TextBox 16"/>
+          <p:cNvSpPr txBox="1"/>
+          <p:nvPr/>
+        </p:nvSpPr>
+        <p:spPr>
+          <a:xfrm>
+            <a:off x="8449056" y="4206240"/>
+            <a:ext cx="2660904" cy="1316736"/>
+          </a:xfrm>
+          <a:prstGeom prst="rect">
+            <a:avLst/>
+          </a:prstGeom>
+          <a:solidFill>
+            <a:srgbClr val="FFFFFF"/>
+          </a:solidFill>
+          <a:ln w="9525">
+            <a:solidFill>
+              <a:srgbClr val="E2E6E3"/>
+            </a:solidFill>
+          </a:ln>
+        </p:spPr>
+        <p:txBody>
+          <a:bodyPr wrap="square" tIns="73152" bIns="73152">
+            <a:noAutofit/>
+          </a:bodyPr>
+          <a:lstStyle/>
+          <a:p>
+            <a:endParaRPr lang="en-US" sz="1200" b="1">
+              <a:solidFill>
+                <a:srgbClr val="15181A"/>
+              </a:solidFill>
+              <a:latin typeface="Arial"/>
+            </a:endParaRPr>
           </a:p>
         </p:txBody>
       </p:sp>
@@ -13549,7 +14438,7 @@
           <a:lstStyle/>
           <a:p>
             <a:r>
-              <a:t>[One line. What the wins have in common.]</a:t>
+              <a:t>Three wins: job, competitor, what won it. One loss: what decided it, what we'd do differently.</a:t>
             </a:r>
           </a:p>
         </p:txBody>
@@ -13564,18 +14453,18 @@
         </p:nvGraphicFramePr>
         <p:xfrm>
           <a:off x="731520" y="2121408"/>
-          <a:ext cx="10725912" cy="3913632"/>
+          <a:ext cx="10725912" cy="3621024"/>
         </p:xfrm>
         <a:graphic>
           <a:graphicData uri="http://schemas.openxmlformats.org/drawingml/2006/table">
             <a:tbl>
               <a:tblPr firstRow="0" bandRow="0"/>
               <a:tblGrid>
-                <a:gridCol w="1097280"/>
-                <a:gridCol w="2743200"/>
-                <a:gridCol w="2011680"/>
-                <a:gridCol w="2468880"/>
-                <a:gridCol w="2404872"/>
+                <a:gridCol w="822960"/>
+                <a:gridCol w="2651760"/>
+                <a:gridCol w="1737360"/>
+                <a:gridCol w="2926080"/>
+                <a:gridCol w="2587752"/>
               </a:tblGrid>
               <a:tr h="365760">
                 <a:tc>
@@ -13584,7 +14473,7 @@
                     <a:lstStyle/>
                     <a:p>
                       <a:r>
-                        <a:rPr sz="1100" b="1">
+                        <a:rPr sz="1000" b="1">
                           <a:solidFill>
                             <a:srgbClr val="FFFFFF"/>
                           </a:solidFill>
@@ -13630,13 +14519,13 @@
                     <a:lstStyle/>
                     <a:p>
                       <a:r>
-                        <a:rPr sz="1100" b="1">
+                        <a:rPr sz="1000" b="1">
                           <a:solidFill>
                             <a:srgbClr val="FFFFFF"/>
                           </a:solidFill>
                           <a:latin typeface="Arial"/>
                         </a:rPr>
-                        <a:t>Job: dealer, account, job name</a:t>
+                        <a:t>Job: account, job name</a:t>
                       </a:r>
                     </a:p>
                   </a:txBody>
@@ -13676,7 +14565,7 @@
                     <a:lstStyle/>
                     <a:p>
                       <a:r>
-                        <a:rPr sz="1100" b="1">
+                        <a:rPr sz="1000" b="1">
                           <a:solidFill>
                             <a:srgbClr val="FFFFFF"/>
                           </a:solidFill>
@@ -13722,13 +14611,13 @@
                     <a:lstStyle/>
                     <a:p>
                       <a:r>
-                        <a:rPr sz="1100" b="1">
+                        <a:rPr sz="1000" b="1">
                           <a:solidFill>
                             <a:srgbClr val="FFFFFF"/>
                           </a:solidFill>
                           <a:latin typeface="Arial"/>
                         </a:rPr>
-                        <a:t>What won it</a:t>
+                        <a:t>What won it  (loss: what decided it)</a:t>
                       </a:r>
                     </a:p>
                   </a:txBody>
@@ -13768,13 +14657,13 @@
                     <a:lstStyle/>
                     <a:p>
                       <a:r>
-                        <a:rPr sz="1100" b="1">
+                        <a:rPr sz="1000" b="1">
                           <a:solidFill>
                             <a:srgbClr val="FFFFFF"/>
                           </a:solidFill>
                           <a:latin typeface="Arial"/>
                         </a:rPr>
-                        <a:t>Repeatable? How</a:t>
+                        <a:t>Can we do it again?  (loss: what we'd change)</a:t>
                       </a:r>
                     </a:p>
                   </a:txBody>
@@ -13809,16 +14698,16 @@
                   </a:tcPr>
                 </a:tc>
               </a:tr>
-              <a:tr h="886968">
+              <a:tr h="841248">
                 <a:tc>
                   <a:txBody>
                     <a:bodyPr/>
                     <a:lstStyle/>
                     <a:p>
                       <a:r>
-                        <a:rPr sz="1100" b="1">
+                        <a:rPr sz="1000" b="1">
                           <a:solidFill>
-                            <a:srgbClr val="15181A"/>
+                            <a:srgbClr val="5B6670"/>
                           </a:solidFill>
                           <a:latin typeface="Arial"/>
                         </a:rPr>
@@ -13826,9 +14715,9 @@
                       </a:r>
                     </a:p>
                   </a:txBody>
-                  <a:tcPr marL="73152" marR="73152" marT="27432" marB="27432" anchor="t">
+                  <a:tcPr marL="73152" marR="73152" marT="36576" marB="36576" anchor="t">
                     <a:solidFill>
-                      <a:srgbClr val="FFFFFF"/>
+                      <a:srgbClr val="F2F5F2"/>
                     </a:solidFill>
                     <a:lnL w="6350" cap="flat" cmpd="sng" algn="ctr">
                       <a:solidFill>
@@ -13861,18 +14750,15 @@
                     <a:bodyPr/>
                     <a:lstStyle/>
                     <a:p>
-                      <a:r>
-                        <a:rPr sz="1100" b="0">
-                          <a:solidFill>
-                            <a:srgbClr val="5B6670"/>
-                          </a:solidFill>
-                          <a:latin typeface="Arial"/>
-                        </a:rPr>
-                        <a:t/>
-                      </a:r>
+                      <a:endParaRPr lang="en-US" sz="1200" b="1">
+                        <a:solidFill>
+                          <a:srgbClr val="15181A"/>
+                        </a:solidFill>
+                        <a:latin typeface="Arial"/>
+                      </a:endParaRPr>
                     </a:p>
                   </a:txBody>
-                  <a:tcPr marL="73152" marR="73152" marT="27432" marB="27432" anchor="t">
+                  <a:tcPr marL="73152" marR="73152" marT="36576" marB="36576" anchor="t">
                     <a:solidFill>
                       <a:srgbClr val="FFFFFF"/>
                     </a:solidFill>
@@ -13907,18 +14793,15 @@
                     <a:bodyPr/>
                     <a:lstStyle/>
                     <a:p>
-                      <a:r>
-                        <a:rPr sz="1100" b="0">
-                          <a:solidFill>
-                            <a:srgbClr val="5B6670"/>
-                          </a:solidFill>
-                          <a:latin typeface="Arial"/>
-                        </a:rPr>
-                        <a:t/>
-                      </a:r>
+                      <a:endParaRPr lang="en-US" sz="1200" b="1">
+                        <a:solidFill>
+                          <a:srgbClr val="15181A"/>
+                        </a:solidFill>
+                        <a:latin typeface="Arial"/>
+                      </a:endParaRPr>
                     </a:p>
                   </a:txBody>
-                  <a:tcPr marL="73152" marR="73152" marT="27432" marB="27432" anchor="t">
+                  <a:tcPr marL="73152" marR="73152" marT="36576" marB="36576" anchor="t">
                     <a:solidFill>
                       <a:srgbClr val="FFFFFF"/>
                     </a:solidFill>
@@ -13953,18 +14836,15 @@
                     <a:bodyPr/>
                     <a:lstStyle/>
                     <a:p>
-                      <a:r>
-                        <a:rPr sz="1100" b="0">
-                          <a:solidFill>
-                            <a:srgbClr val="5B6670"/>
-                          </a:solidFill>
-                          <a:latin typeface="Arial"/>
-                        </a:rPr>
-                        <a:t/>
-                      </a:r>
+                      <a:endParaRPr lang="en-US" sz="1200" b="1">
+                        <a:solidFill>
+                          <a:srgbClr val="15181A"/>
+                        </a:solidFill>
+                        <a:latin typeface="Arial"/>
+                      </a:endParaRPr>
                     </a:p>
                   </a:txBody>
-                  <a:tcPr marL="73152" marR="73152" marT="27432" marB="27432" anchor="t">
+                  <a:tcPr marL="73152" marR="73152" marT="36576" marB="36576" anchor="t">
                     <a:solidFill>
                       <a:srgbClr val="FFFFFF"/>
                     </a:solidFill>
@@ -13999,18 +14879,15 @@
                     <a:bodyPr/>
                     <a:lstStyle/>
                     <a:p>
-                      <a:r>
-                        <a:rPr sz="1100" b="0">
-                          <a:solidFill>
-                            <a:srgbClr val="5B6670"/>
-                          </a:solidFill>
-                          <a:latin typeface="Arial"/>
-                        </a:rPr>
-                        <a:t/>
-                      </a:r>
+                      <a:endParaRPr lang="en-US" sz="1200" b="1">
+                        <a:solidFill>
+                          <a:srgbClr val="15181A"/>
+                        </a:solidFill>
+                        <a:latin typeface="Arial"/>
+                      </a:endParaRPr>
                     </a:p>
                   </a:txBody>
-                  <a:tcPr marL="73152" marR="73152" marT="27432" marB="27432" anchor="t">
+                  <a:tcPr marL="73152" marR="73152" marT="36576" marB="36576" anchor="t">
                     <a:solidFill>
                       <a:srgbClr val="FFFFFF"/>
                     </a:solidFill>
@@ -14041,16 +14918,16 @@
                   </a:tcPr>
                 </a:tc>
               </a:tr>
-              <a:tr h="886968">
+              <a:tr h="841248">
                 <a:tc>
                   <a:txBody>
                     <a:bodyPr/>
                     <a:lstStyle/>
                     <a:p>
                       <a:r>
-                        <a:rPr sz="1100" b="1">
+                        <a:rPr sz="1000" b="1">
                           <a:solidFill>
-                            <a:srgbClr val="15181A"/>
+                            <a:srgbClr val="5B6670"/>
                           </a:solidFill>
                           <a:latin typeface="Arial"/>
                         </a:rPr>
@@ -14058,9 +14935,9 @@
                       </a:r>
                     </a:p>
                   </a:txBody>
-                  <a:tcPr marL="73152" marR="73152" marT="27432" marB="27432" anchor="t">
+                  <a:tcPr marL="73152" marR="73152" marT="36576" marB="36576" anchor="t">
                     <a:solidFill>
-                      <a:srgbClr val="FFFFFF"/>
+                      <a:srgbClr val="F2F5F2"/>
                     </a:solidFill>
                     <a:lnL w="6350" cap="flat" cmpd="sng" algn="ctr">
                       <a:solidFill>
@@ -14093,18 +14970,15 @@
                     <a:bodyPr/>
                     <a:lstStyle/>
                     <a:p>
-                      <a:r>
-                        <a:rPr sz="1100" b="0">
-                          <a:solidFill>
-                            <a:srgbClr val="5B6670"/>
-                          </a:solidFill>
-                          <a:latin typeface="Arial"/>
-                        </a:rPr>
-                        <a:t/>
-                      </a:r>
+                      <a:endParaRPr lang="en-US" sz="1200" b="1">
+                        <a:solidFill>
+                          <a:srgbClr val="15181A"/>
+                        </a:solidFill>
+                        <a:latin typeface="Arial"/>
+                      </a:endParaRPr>
                     </a:p>
                   </a:txBody>
-                  <a:tcPr marL="73152" marR="73152" marT="27432" marB="27432" anchor="t">
+                  <a:tcPr marL="73152" marR="73152" marT="36576" marB="36576" anchor="t">
                     <a:solidFill>
                       <a:srgbClr val="FFFFFF"/>
                     </a:solidFill>
@@ -14139,18 +15013,15 @@
                     <a:bodyPr/>
                     <a:lstStyle/>
                     <a:p>
-                      <a:r>
-                        <a:rPr sz="1100" b="0">
-                          <a:solidFill>
-                            <a:srgbClr val="5B6670"/>
-                          </a:solidFill>
-                          <a:latin typeface="Arial"/>
-                        </a:rPr>
-                        <a:t/>
-                      </a:r>
+                      <a:endParaRPr lang="en-US" sz="1200" b="1">
+                        <a:solidFill>
+                          <a:srgbClr val="15181A"/>
+                        </a:solidFill>
+                        <a:latin typeface="Arial"/>
+                      </a:endParaRPr>
                     </a:p>
                   </a:txBody>
-                  <a:tcPr marL="73152" marR="73152" marT="27432" marB="27432" anchor="t">
+                  <a:tcPr marL="73152" marR="73152" marT="36576" marB="36576" anchor="t">
                     <a:solidFill>
                       <a:srgbClr val="FFFFFF"/>
                     </a:solidFill>
@@ -14185,18 +15056,15 @@
                     <a:bodyPr/>
                     <a:lstStyle/>
                     <a:p>
-                      <a:r>
-                        <a:rPr sz="1100" b="0">
-                          <a:solidFill>
-                            <a:srgbClr val="5B6670"/>
-                          </a:solidFill>
-                          <a:latin typeface="Arial"/>
-                        </a:rPr>
-                        <a:t/>
-                      </a:r>
+                      <a:endParaRPr lang="en-US" sz="1200" b="1">
+                        <a:solidFill>
+                          <a:srgbClr val="15181A"/>
+                        </a:solidFill>
+                        <a:latin typeface="Arial"/>
+                      </a:endParaRPr>
                     </a:p>
                   </a:txBody>
-                  <a:tcPr marL="73152" marR="73152" marT="27432" marB="27432" anchor="t">
+                  <a:tcPr marL="73152" marR="73152" marT="36576" marB="36576" anchor="t">
                     <a:solidFill>
                       <a:srgbClr val="FFFFFF"/>
                     </a:solidFill>
@@ -14231,18 +15099,15 @@
                     <a:bodyPr/>
                     <a:lstStyle/>
                     <a:p>
-                      <a:r>
-                        <a:rPr sz="1100" b="0">
-                          <a:solidFill>
-                            <a:srgbClr val="5B6670"/>
-                          </a:solidFill>
-                          <a:latin typeface="Arial"/>
-                        </a:rPr>
-                        <a:t/>
-                      </a:r>
+                      <a:endParaRPr lang="en-US" sz="1200" b="1">
+                        <a:solidFill>
+                          <a:srgbClr val="15181A"/>
+                        </a:solidFill>
+                        <a:latin typeface="Arial"/>
+                      </a:endParaRPr>
                     </a:p>
                   </a:txBody>
-                  <a:tcPr marL="73152" marR="73152" marT="27432" marB="27432" anchor="t">
+                  <a:tcPr marL="73152" marR="73152" marT="36576" marB="36576" anchor="t">
                     <a:solidFill>
                       <a:srgbClr val="FFFFFF"/>
                     </a:solidFill>
@@ -14273,16 +15138,16 @@
                   </a:tcPr>
                 </a:tc>
               </a:tr>
-              <a:tr h="886968">
+              <a:tr h="841248">
                 <a:tc>
                   <a:txBody>
                     <a:bodyPr/>
                     <a:lstStyle/>
                     <a:p>
                       <a:r>
-                        <a:rPr sz="1100" b="1">
+                        <a:rPr sz="1000" b="1">
                           <a:solidFill>
-                            <a:srgbClr val="15181A"/>
+                            <a:srgbClr val="5B6670"/>
                           </a:solidFill>
                           <a:latin typeface="Arial"/>
                         </a:rPr>
@@ -14290,9 +15155,9 @@
                       </a:r>
                     </a:p>
                   </a:txBody>
-                  <a:tcPr marL="73152" marR="73152" marT="27432" marB="27432" anchor="t">
+                  <a:tcPr marL="73152" marR="73152" marT="36576" marB="36576" anchor="t">
                     <a:solidFill>
-                      <a:srgbClr val="FFFFFF"/>
+                      <a:srgbClr val="F2F5F2"/>
                     </a:solidFill>
                     <a:lnL w="6350" cap="flat" cmpd="sng" algn="ctr">
                       <a:solidFill>
@@ -14325,18 +15190,15 @@
                     <a:bodyPr/>
                     <a:lstStyle/>
                     <a:p>
-                      <a:r>
-                        <a:rPr sz="1100" b="0">
-                          <a:solidFill>
-                            <a:srgbClr val="5B6670"/>
-                          </a:solidFill>
-                          <a:latin typeface="Arial"/>
-                        </a:rPr>
-                        <a:t/>
-                      </a:r>
+                      <a:endParaRPr lang="en-US" sz="1200" b="1">
+                        <a:solidFill>
+                          <a:srgbClr val="15181A"/>
+                        </a:solidFill>
+                        <a:latin typeface="Arial"/>
+                      </a:endParaRPr>
                     </a:p>
                   </a:txBody>
-                  <a:tcPr marL="73152" marR="73152" marT="27432" marB="27432" anchor="t">
+                  <a:tcPr marL="73152" marR="73152" marT="36576" marB="36576" anchor="t">
                     <a:solidFill>
                       <a:srgbClr val="FFFFFF"/>
                     </a:solidFill>
@@ -14371,18 +15233,15 @@
                     <a:bodyPr/>
                     <a:lstStyle/>
                     <a:p>
-                      <a:r>
-                        <a:rPr sz="1100" b="0">
-                          <a:solidFill>
-                            <a:srgbClr val="5B6670"/>
-                          </a:solidFill>
-                          <a:latin typeface="Arial"/>
-                        </a:rPr>
-                        <a:t/>
-                      </a:r>
+                      <a:endParaRPr lang="en-US" sz="1200" b="1">
+                        <a:solidFill>
+                          <a:srgbClr val="15181A"/>
+                        </a:solidFill>
+                        <a:latin typeface="Arial"/>
+                      </a:endParaRPr>
                     </a:p>
                   </a:txBody>
-                  <a:tcPr marL="73152" marR="73152" marT="27432" marB="27432" anchor="t">
+                  <a:tcPr marL="73152" marR="73152" marT="36576" marB="36576" anchor="t">
                     <a:solidFill>
                       <a:srgbClr val="FFFFFF"/>
                     </a:solidFill>
@@ -14417,18 +15276,15 @@
                     <a:bodyPr/>
                     <a:lstStyle/>
                     <a:p>
-                      <a:r>
-                        <a:rPr sz="1100" b="0">
-                          <a:solidFill>
-                            <a:srgbClr val="5B6670"/>
-                          </a:solidFill>
-                          <a:latin typeface="Arial"/>
-                        </a:rPr>
-                        <a:t/>
-                      </a:r>
+                      <a:endParaRPr lang="en-US" sz="1200" b="1">
+                        <a:solidFill>
+                          <a:srgbClr val="15181A"/>
+                        </a:solidFill>
+                        <a:latin typeface="Arial"/>
+                      </a:endParaRPr>
                     </a:p>
                   </a:txBody>
-                  <a:tcPr marL="73152" marR="73152" marT="27432" marB="27432" anchor="t">
+                  <a:tcPr marL="73152" marR="73152" marT="36576" marB="36576" anchor="t">
                     <a:solidFill>
                       <a:srgbClr val="FFFFFF"/>
                     </a:solidFill>
@@ -14463,18 +15319,15 @@
                     <a:bodyPr/>
                     <a:lstStyle/>
                     <a:p>
-                      <a:r>
-                        <a:rPr sz="1100" b="0">
-                          <a:solidFill>
-                            <a:srgbClr val="5B6670"/>
-                          </a:solidFill>
-                          <a:latin typeface="Arial"/>
-                        </a:rPr>
-                        <a:t/>
-                      </a:r>
+                      <a:endParaRPr lang="en-US" sz="1200" b="1">
+                        <a:solidFill>
+                          <a:srgbClr val="15181A"/>
+                        </a:solidFill>
+                        <a:latin typeface="Arial"/>
+                      </a:endParaRPr>
                     </a:p>
                   </a:txBody>
-                  <a:tcPr marL="73152" marR="73152" marT="27432" marB="27432" anchor="t">
+                  <a:tcPr marL="73152" marR="73152" marT="36576" marB="36576" anchor="t">
                     <a:solidFill>
                       <a:srgbClr val="FFFFFF"/>
                     </a:solidFill>
@@ -14505,16 +15358,16 @@
                   </a:tcPr>
                 </a:tc>
               </a:tr>
-              <a:tr h="886968">
+              <a:tr h="731520">
                 <a:tc>
                   <a:txBody>
                     <a:bodyPr/>
                     <a:lstStyle/>
                     <a:p>
                       <a:r>
-                        <a:rPr sz="1100" b="1">
+                        <a:rPr sz="1000" b="1">
                           <a:solidFill>
-                            <a:srgbClr val="15181A"/>
+                            <a:srgbClr val="5B6670"/>
                           </a:solidFill>
                           <a:latin typeface="Arial"/>
                         </a:rPr>
@@ -14522,9 +15375,9 @@
                       </a:r>
                     </a:p>
                   </a:txBody>
-                  <a:tcPr marL="73152" marR="73152" marT="27432" marB="27432" anchor="t">
+                  <a:tcPr marL="73152" marR="73152" marT="36576" marB="36576" anchor="t">
                     <a:solidFill>
-                      <a:srgbClr val="FFFFFF"/>
+                      <a:srgbClr val="F2F5F2"/>
                     </a:solidFill>
                     <a:lnL w="6350" cap="flat" cmpd="sng" algn="ctr">
                       <a:solidFill>
@@ -14557,18 +15410,15 @@
                     <a:bodyPr/>
                     <a:lstStyle/>
                     <a:p>
-                      <a:r>
-                        <a:rPr sz="1100" b="0">
-                          <a:solidFill>
-                            <a:srgbClr val="5B6670"/>
-                          </a:solidFill>
-                          <a:latin typeface="Arial"/>
-                        </a:rPr>
-                        <a:t/>
-                      </a:r>
+                      <a:endParaRPr lang="en-US" sz="1200" b="1">
+                        <a:solidFill>
+                          <a:srgbClr val="15181A"/>
+                        </a:solidFill>
+                        <a:latin typeface="Arial"/>
+                      </a:endParaRPr>
                     </a:p>
                   </a:txBody>
-                  <a:tcPr marL="73152" marR="73152" marT="27432" marB="27432" anchor="t">
+                  <a:tcPr marL="73152" marR="73152" marT="36576" marB="36576" anchor="t">
                     <a:solidFill>
                       <a:srgbClr val="FFFFFF"/>
                     </a:solidFill>
@@ -14603,18 +15453,15 @@
                     <a:bodyPr/>
                     <a:lstStyle/>
                     <a:p>
-                      <a:r>
-                        <a:rPr sz="1100" b="0">
-                          <a:solidFill>
-                            <a:srgbClr val="5B6670"/>
-                          </a:solidFill>
-                          <a:latin typeface="Arial"/>
-                        </a:rPr>
-                        <a:t/>
-                      </a:r>
+                      <a:endParaRPr lang="en-US" sz="1200" b="1">
+                        <a:solidFill>
+                          <a:srgbClr val="15181A"/>
+                        </a:solidFill>
+                        <a:latin typeface="Arial"/>
+                      </a:endParaRPr>
                     </a:p>
                   </a:txBody>
-                  <a:tcPr marL="73152" marR="73152" marT="27432" marB="27432" anchor="t">
+                  <a:tcPr marL="73152" marR="73152" marT="36576" marB="36576" anchor="t">
                     <a:solidFill>
                       <a:srgbClr val="FFFFFF"/>
                     </a:solidFill>
@@ -14649,18 +15496,15 @@
                     <a:bodyPr/>
                     <a:lstStyle/>
                     <a:p>
-                      <a:r>
-                        <a:rPr sz="1100" b="0">
-                          <a:solidFill>
-                            <a:srgbClr val="5B6670"/>
-                          </a:solidFill>
-                          <a:latin typeface="Arial"/>
-                        </a:rPr>
-                        <a:t>What decided it, and what else was true</a:t>
-                      </a:r>
+                      <a:endParaRPr lang="en-US" sz="1200" b="1">
+                        <a:solidFill>
+                          <a:srgbClr val="15181A"/>
+                        </a:solidFill>
+                        <a:latin typeface="Arial"/>
+                      </a:endParaRPr>
                     </a:p>
                   </a:txBody>
-                  <a:tcPr marL="73152" marR="73152" marT="27432" marB="27432" anchor="t">
+                  <a:tcPr marL="73152" marR="73152" marT="36576" marB="36576" anchor="t">
                     <a:solidFill>
                       <a:srgbClr val="FFFFFF"/>
                     </a:solidFill>
@@ -14695,18 +15539,15 @@
                     <a:bodyPr/>
                     <a:lstStyle/>
                     <a:p>
-                      <a:r>
-                        <a:rPr sz="1100" b="0">
-                          <a:solidFill>
-                            <a:srgbClr val="5B6670"/>
-                          </a:solidFill>
-                          <a:latin typeface="Arial"/>
-                        </a:rPr>
-                        <a:t>What we could have done differently</a:t>
-                      </a:r>
+                      <a:endParaRPr lang="en-US" sz="1200" b="1">
+                        <a:solidFill>
+                          <a:srgbClr val="15181A"/>
+                        </a:solidFill>
+                        <a:latin typeface="Arial"/>
+                      </a:endParaRPr>
                     </a:p>
                   </a:txBody>
-                  <a:tcPr marL="73152" marR="73152" marT="27432" marB="27432" anchor="t">
+                  <a:tcPr marL="73152" marR="73152" marT="36576" marB="36576" anchor="t">
                     <a:solidFill>
                       <a:srgbClr val="FFFFFF"/>
                     </a:solidFill>
@@ -14741,6 +15582,41 @@
           </a:graphicData>
         </a:graphic>
       </p:graphicFrame>
+      <p:sp>
+        <p:nvSpPr>
+          <p:cNvPr id="6" name="TextBox 5"/>
+          <p:cNvSpPr txBox="1"/>
+          <p:nvPr/>
+        </p:nvSpPr>
+        <p:spPr>
+          <a:xfrm>
+            <a:off x="731520" y="5797296"/>
+            <a:ext cx="10725912" cy="237744"/>
+          </a:xfrm>
+          <a:prstGeom prst="rect">
+            <a:avLst/>
+          </a:prstGeom>
+          <a:noFill/>
+        </p:spPr>
+        <p:txBody>
+          <a:bodyPr wrap="square" lIns="0" rIns="0" tIns="0" bIns="0">
+            <a:noAutofit/>
+          </a:bodyPr>
+          <a:lstStyle/>
+          <a:p>
+            <a:pPr algn="l"/>
+            <a:r>
+              <a:rPr sz="1100" b="1" i="0">
+                <a:solidFill>
+                  <a:srgbClr val="3C7D4D"/>
+                </a:solidFill>
+                <a:latin typeface="Arial"/>
+              </a:rPr>
+              <a:t>For the room:  What won it, and can the rest of us do the same thing?</a:t>
+            </a:r>
+          </a:p>
+        </p:txBody>
+      </p:sp>
     </p:spTree>
   </p:cSld>
   <p:clrMapOvr>
@@ -14817,7 +15693,7 @@
           <a:lstStyle/>
           <a:p>
             <a:r>
-              <a:t>[One line. What Q4 looks like if these land.]</a:t>
+              <a:t>Three projects, one you'll grow, and one thing you'd change about how we run sales.</a:t>
             </a:r>
           </a:p>
         </p:txBody>
@@ -14845,37 +15721,6 @@
       </p:sp>
       <p:sp>
         <p:nvSpPr>
-          <p:cNvPr id="6" name="Text Placeholder 5"/>
-          <p:cNvSpPr>
-            <a:spLocks noGrp="1"/>
-          </p:cNvSpPr>
-          <p:nvPr>
-            <p:ph type="body" idx="107"/>
-          </p:nvPr>
-        </p:nvSpPr>
-        <p:spPr/>
-        <p:txBody>
-          <a:bodyPr/>
-          <a:lstStyle/>
-          <a:p>
-            <a:r>
-              <a:t>1. [Job, $, close date]</a:t>
-            </a:r>
-          </a:p>
-          <a:p>
-            <a:r>
-              <a:t>2. [Job, $, close date]</a:t>
-            </a:r>
-          </a:p>
-          <a:p>
-            <a:r>
-              <a:t>3. [Job, $, close date]</a:t>
-            </a:r>
-          </a:p>
-        </p:txBody>
-      </p:sp>
-      <p:sp>
-        <p:nvSpPr>
           <p:cNvPr id="7" name="Text Placeholder 6"/>
           <p:cNvSpPr>
             <a:spLocks noGrp="1"/>
@@ -14897,42 +15742,6 @@
       </p:sp>
       <p:sp>
         <p:nvSpPr>
-          <p:cNvPr id="8" name="Text Placeholder 7"/>
-          <p:cNvSpPr>
-            <a:spLocks noGrp="1"/>
-          </p:cNvSpPr>
-          <p:nvPr>
-            <p:ph type="body" idx="112"/>
-          </p:nvPr>
-        </p:nvSpPr>
-        <p:spPr/>
-        <p:txBody>
-          <a:bodyPr/>
-          <a:lstStyle/>
-          <a:p>
-            <a:r>
-              <a:t>Account: [name]</a:t>
-            </a:r>
-          </a:p>
-          <a:p>
-            <a:r>
-              <a:t>From: [today]</a:t>
-            </a:r>
-          </a:p>
-          <a:p>
-            <a:r>
-              <a:t>To: [target]</a:t>
-            </a:r>
-          </a:p>
-          <a:p>
-            <a:r>
-              <a:t>How: [the specific move]</a:t>
-            </a:r>
-          </a:p>
-        </p:txBody>
-      </p:sp>
-      <p:sp>
-        <p:nvSpPr>
           <p:cNvPr id="9" name="Text Placeholder 8"/>
           <p:cNvSpPr>
             <a:spLocks noGrp="1"/>
@@ -14954,32 +15763,220 @@
       </p:sp>
       <p:sp>
         <p:nvSpPr>
-          <p:cNvPr id="10" name="Text Placeholder 9"/>
-          <p:cNvSpPr>
-            <a:spLocks noGrp="1"/>
-          </p:cNvSpPr>
-          <p:nvPr>
-            <p:ph type="body" idx="117"/>
-          </p:nvPr>
-        </p:nvSpPr>
-        <p:spPr/>
-        <p:txBody>
-          <a:bodyPr/>
+          <p:cNvPr id="12" name="TextBox 11"/>
+          <p:cNvSpPr txBox="1"/>
+          <p:nvPr/>
+        </p:nvSpPr>
+        <p:spPr>
+          <a:xfrm>
+            <a:off x="1097280" y="3931920"/>
+            <a:ext cx="2660904" cy="237744"/>
+          </a:xfrm>
+          <a:prstGeom prst="rect">
+            <a:avLst/>
+          </a:prstGeom>
+          <a:noFill/>
+        </p:spPr>
+        <p:txBody>
+          <a:bodyPr wrap="square" lIns="0" rIns="0" tIns="0" bIns="0">
+            <a:noAutofit/>
+          </a:bodyPr>
           <a:lstStyle/>
           <a:p>
-            <a:r>
-              <a:t>What: [about how we run sales]</a:t>
-            </a:r>
-          </a:p>
-          <a:p>
-            <a:r>
-              <a:t>Why: [ ]</a:t>
-            </a:r>
-          </a:p>
-          <a:p>
-            <a:r>
-              <a:t>What it would take: [ ]</a:t>
-            </a:r>
+            <a:pPr algn="l"/>
+            <a:r>
+              <a:rPr sz="1000" b="0" i="0">
+                <a:solidFill>
+                  <a:srgbClr val="5B6670"/>
+                </a:solidFill>
+                <a:latin typeface="Arial"/>
+              </a:rPr>
+              <a:t>Job, dollars, close date</a:t>
+            </a:r>
+          </a:p>
+        </p:txBody>
+      </p:sp>
+      <p:sp>
+        <p:nvSpPr>
+          <p:cNvPr id="13" name="TextBox 12"/>
+          <p:cNvSpPr txBox="1"/>
+          <p:nvPr/>
+        </p:nvSpPr>
+        <p:spPr>
+          <a:xfrm>
+            <a:off x="1097280" y="4206240"/>
+            <a:ext cx="2660904" cy="1316736"/>
+          </a:xfrm>
+          <a:prstGeom prst="rect">
+            <a:avLst/>
+          </a:prstGeom>
+          <a:solidFill>
+            <a:srgbClr val="FFFFFF"/>
+          </a:solidFill>
+          <a:ln w="9525">
+            <a:solidFill>
+              <a:srgbClr val="E2E6E3"/>
+            </a:solidFill>
+          </a:ln>
+        </p:spPr>
+        <p:txBody>
+          <a:bodyPr wrap="square" tIns="73152" bIns="73152">
+            <a:noAutofit/>
+          </a:bodyPr>
+          <a:lstStyle/>
+          <a:p>
+            <a:endParaRPr lang="en-US" sz="1200" b="1">
+              <a:solidFill>
+                <a:srgbClr val="15181A"/>
+              </a:solidFill>
+              <a:latin typeface="Arial"/>
+            </a:endParaRPr>
+          </a:p>
+        </p:txBody>
+      </p:sp>
+      <p:sp>
+        <p:nvSpPr>
+          <p:cNvPr id="14" name="TextBox 13"/>
+          <p:cNvSpPr txBox="1"/>
+          <p:nvPr/>
+        </p:nvSpPr>
+        <p:spPr>
+          <a:xfrm>
+            <a:off x="4773168" y="3931920"/>
+            <a:ext cx="2660904" cy="237744"/>
+          </a:xfrm>
+          <a:prstGeom prst="rect">
+            <a:avLst/>
+          </a:prstGeom>
+          <a:noFill/>
+        </p:spPr>
+        <p:txBody>
+          <a:bodyPr wrap="square" lIns="0" rIns="0" tIns="0" bIns="0">
+            <a:noAutofit/>
+          </a:bodyPr>
+          <a:lstStyle/>
+          <a:p>
+            <a:pPr algn="l"/>
+            <a:r>
+              <a:rPr sz="1000" b="0" i="0">
+                <a:solidFill>
+                  <a:srgbClr val="5B6670"/>
+                </a:solidFill>
+                <a:latin typeface="Arial"/>
+              </a:rPr>
+              <a:t>Account, from, to, how</a:t>
+            </a:r>
+          </a:p>
+        </p:txBody>
+      </p:sp>
+      <p:sp>
+        <p:nvSpPr>
+          <p:cNvPr id="15" name="TextBox 14"/>
+          <p:cNvSpPr txBox="1"/>
+          <p:nvPr/>
+        </p:nvSpPr>
+        <p:spPr>
+          <a:xfrm>
+            <a:off x="4773168" y="4206240"/>
+            <a:ext cx="2660904" cy="1316736"/>
+          </a:xfrm>
+          <a:prstGeom prst="rect">
+            <a:avLst/>
+          </a:prstGeom>
+          <a:solidFill>
+            <a:srgbClr val="FFFFFF"/>
+          </a:solidFill>
+          <a:ln w="9525">
+            <a:solidFill>
+              <a:srgbClr val="E2E6E3"/>
+            </a:solidFill>
+          </a:ln>
+        </p:spPr>
+        <p:txBody>
+          <a:bodyPr wrap="square" tIns="73152" bIns="73152">
+            <a:noAutofit/>
+          </a:bodyPr>
+          <a:lstStyle/>
+          <a:p>
+            <a:endParaRPr lang="en-US" sz="1200" b="1">
+              <a:solidFill>
+                <a:srgbClr val="15181A"/>
+              </a:solidFill>
+              <a:latin typeface="Arial"/>
+            </a:endParaRPr>
+          </a:p>
+        </p:txBody>
+      </p:sp>
+      <p:sp>
+        <p:nvSpPr>
+          <p:cNvPr id="16" name="TextBox 15"/>
+          <p:cNvSpPr txBox="1"/>
+          <p:nvPr/>
+        </p:nvSpPr>
+        <p:spPr>
+          <a:xfrm>
+            <a:off x="8449056" y="3931920"/>
+            <a:ext cx="2660904" cy="237744"/>
+          </a:xfrm>
+          <a:prstGeom prst="rect">
+            <a:avLst/>
+          </a:prstGeom>
+          <a:noFill/>
+        </p:spPr>
+        <p:txBody>
+          <a:bodyPr wrap="square" lIns="0" rIns="0" tIns="0" bIns="0">
+            <a:noAutofit/>
+          </a:bodyPr>
+          <a:lstStyle/>
+          <a:p>
+            <a:pPr algn="l"/>
+            <a:r>
+              <a:rPr sz="1000" b="0" i="0">
+                <a:solidFill>
+                  <a:srgbClr val="5B6670"/>
+                </a:solidFill>
+                <a:latin typeface="Arial"/>
+              </a:rPr>
+              <a:t>About how we run sales. What, and why.</a:t>
+            </a:r>
+          </a:p>
+        </p:txBody>
+      </p:sp>
+      <p:sp>
+        <p:nvSpPr>
+          <p:cNvPr id="17" name="TextBox 16"/>
+          <p:cNvSpPr txBox="1"/>
+          <p:nvPr/>
+        </p:nvSpPr>
+        <p:spPr>
+          <a:xfrm>
+            <a:off x="8449056" y="4206240"/>
+            <a:ext cx="2660904" cy="1316736"/>
+          </a:xfrm>
+          <a:prstGeom prst="rect">
+            <a:avLst/>
+          </a:prstGeom>
+          <a:solidFill>
+            <a:srgbClr val="FFFFFF"/>
+          </a:solidFill>
+          <a:ln w="9525">
+            <a:solidFill>
+              <a:srgbClr val="E2E6E3"/>
+            </a:solidFill>
+          </a:ln>
+        </p:spPr>
+        <p:txBody>
+          <a:bodyPr wrap="square" tIns="73152" bIns="73152">
+            <a:noAutofit/>
+          </a:bodyPr>
+          <a:lstStyle/>
+          <a:p>
+            <a:endParaRPr lang="en-US" sz="1200" b="1">
+              <a:solidFill>
+                <a:srgbClr val="15181A"/>
+              </a:solidFill>
+              <a:latin typeface="Arial"/>
+            </a:endParaRPr>
           </a:p>
         </p:txBody>
       </p:sp>

</xml_diff>